<commit_message>
FIX: presentation & pres text
</commit_message>
<xml_diff>
--- a/master/Diploma/presentation/OnyushevA_RK6-41M.pptx
+++ b/master/Diploma/presentation/OnyushevA_RK6-41M.pptx
@@ -210,7 +210,7 @@
           <a:p>
             <a:fld id="{3F3CFF3B-98A7-41B4-A722-42506241E61D}" type="datetimeFigureOut">
               <a:rPr lang="en-US" smtClean="0"/>
-              <a:t>5/2/2026</a:t>
+              <a:t>5/11/2026</a:t>
             </a:fld>
             <a:endParaRPr lang="en-US"/>
           </a:p>
@@ -521,54 +521,45 @@
           <a:bodyPr/>
           <a:lstStyle/>
           <a:p>
-            <a:pPr marL="0" marR="0" lvl="0" indent="0" algn="l" defTabSz="914400" rtl="0" eaLnBrk="1" fontAlgn="auto" latinLnBrk="0" hangingPunct="1">
-              <a:lnSpc>
-                <a:spcPct val="100000"/>
-              </a:lnSpc>
-              <a:spcBef>
-                <a:spcPts val="0"/>
-              </a:spcBef>
-              <a:spcAft>
-                <a:spcPts val="0"/>
-              </a:spcAft>
-              <a:buClrTx/>
-              <a:buSzTx/>
-              <a:buFontTx/>
-              <a:buNone/>
-              <a:tabLst/>
-              <a:defRPr/>
-            </a:pPr>
-            <a:r>
-              <a:rPr lang="ru-RU" sz="1800" dirty="0">
-                <a:effectLst/>
-                <a:latin typeface="Times New Roman" panose="02020603050405020304" pitchFamily="18" charset="0"/>
-                <a:ea typeface="Calibri" panose="020F0502020204030204" pitchFamily="34" charset="0"/>
-                <a:cs typeface="Times New Roman" panose="02020603050405020304" pitchFamily="18" charset="0"/>
-              </a:rPr>
-              <a:t>Добрый день, уважаемые члены комиссии, хочу представить вашему вниманию свою выпускную квалификационную работу на тему «</a:t>
-            </a:r>
-            <a:r>
-              <a:rPr lang="ru-RU" sz="1800" b="1" i="1" dirty="0"/>
-              <a:t>Исследование и разработка образовательной платформы с курсами</a:t>
-            </a:r>
-            <a:r>
-              <a:rPr lang="ru-RU" sz="1800" dirty="0">
-                <a:effectLst/>
-                <a:latin typeface="Times New Roman" panose="02020603050405020304" pitchFamily="18" charset="0"/>
-                <a:ea typeface="Calibri" panose="020F0502020204030204" pitchFamily="34" charset="0"/>
-                <a:cs typeface="Times New Roman" panose="02020603050405020304" pitchFamily="18" charset="0"/>
-              </a:rPr>
-              <a:t>»</a:t>
-            </a:r>
-            <a:endParaRPr lang="en-US" sz="1800" dirty="0">
-              <a:effectLst/>
-              <a:latin typeface="Calibri" panose="020F0502020204030204" pitchFamily="34" charset="0"/>
-              <a:ea typeface="Calibri" panose="020F0502020204030204" pitchFamily="34" charset="0"/>
-              <a:cs typeface="Times New Roman" panose="02020603050405020304" pitchFamily="18" charset="0"/>
-            </a:endParaRPr>
-          </a:p>
-          <a:p>
-            <a:endParaRPr lang="en-US" dirty="0"/>
+            <a:r>
+              <a:rPr lang="ru-RU" sz="1800" dirty="0"/>
+              <a:t>Добрый день, уважаемые члены государственной экзаменационной комиссии.</a:t>
+            </a:r>
+            <a:br>
+              <a:rPr lang="ru-RU" sz="1800" dirty="0"/>
+            </a:br>
+            <a:r>
+              <a:rPr lang="ru-RU" sz="1800" dirty="0"/>
+              <a:t>Меня зовут Онюшев Артем Андреевич, группа РК6-41М.</a:t>
+            </a:r>
+            <a:br>
+              <a:rPr lang="ru-RU" sz="1800" dirty="0"/>
+            </a:br>
+            <a:r>
+              <a:rPr lang="ru-RU" sz="1800" dirty="0"/>
+              <a:t>Тема моей выпускной квалификационной работы: </a:t>
+            </a:r>
+            <a:r>
+              <a:rPr lang="ru-RU" sz="1800" b="1" dirty="0"/>
+              <a:t>«Исследование и разработка образовательной платформы с курсами»</a:t>
+            </a:r>
+            <a:r>
+              <a:rPr lang="ru-RU" sz="1800" dirty="0"/>
+              <a:t>.</a:t>
+            </a:r>
+            <a:br>
+              <a:rPr lang="ru-RU" sz="1800" dirty="0"/>
+            </a:br>
+            <a:r>
+              <a:rPr lang="ru-RU" sz="1800" dirty="0"/>
+              <a:t>Научный руководитель работы — Витюков Фёдор Андреевич.</a:t>
+            </a:r>
+          </a:p>
+          <a:p>
+            <a:r>
+              <a:rPr lang="ru-RU" sz="1800" dirty="0"/>
+              <a:t>В своей работе я рассматривал задачи проектирования и разработки современной образовательной платформы, включающей систему авторизации и разграничения доступа, курсы, видеоуроки, онлайн-эфиры, уведомления и чаты.</a:t>
+            </a:r>
           </a:p>
         </p:txBody>
       </p:sp>
@@ -652,404 +643,78 @@
           <a:bodyPr/>
           <a:lstStyle/>
           <a:p>
-            <a:pPr>
-              <a:lnSpc>
-                <a:spcPct val="107000"/>
-              </a:lnSpc>
-              <a:spcAft>
-                <a:spcPts val="800"/>
-              </a:spcAft>
-              <a:tabLst>
-                <a:tab pos="2125980" algn="l"/>
-              </a:tabLst>
+            <a:r>
+              <a:rPr lang="ru-RU" sz="1800" dirty="0"/>
+              <a:t>На этом слайде представлена структура онлайн-эфира.</a:t>
+            </a:r>
+          </a:p>
+          <a:p>
+            <a:r>
+              <a:rPr lang="ru-RU" sz="1800" dirty="0"/>
+              <a:t>Эфир является важной сущностью платформы.</a:t>
+            </a:r>
+          </a:p>
+          <a:p>
+            <a:r>
+              <a:rPr lang="ru-RU" sz="1800" dirty="0"/>
+              <a:t>При проектировании этой подсистемы было важно обеспечить:</a:t>
+            </a:r>
+          </a:p>
+          <a:p>
+            <a:pPr marL="285750" indent="-285750">
+              <a:buFont typeface="Arial" panose="020B0604020202020204" pitchFamily="34" charset="0"/>
+              <a:buChar char="•"/>
             </a:pPr>
             <a:r>
-              <a:rPr lang="ru-RU" sz="1800" dirty="0">
-                <a:effectLst/>
-                <a:latin typeface="Times New Roman" panose="02020603050405020304" pitchFamily="18" charset="0"/>
-                <a:ea typeface="Calibri" panose="020F0502020204030204" pitchFamily="34" charset="0"/>
-                <a:cs typeface="Times New Roman" panose="02020603050405020304" pitchFamily="18" charset="0"/>
-              </a:rPr>
-              <a:t>Проекционная матрица.</a:t>
-            </a:r>
-          </a:p>
-          <a:p>
-            <a:pPr>
-              <a:lnSpc>
-                <a:spcPct val="107000"/>
-              </a:lnSpc>
-              <a:spcAft>
-                <a:spcPts val="800"/>
-              </a:spcAft>
-              <a:tabLst>
-                <a:tab pos="2125980" algn="l"/>
-              </a:tabLst>
+              <a:rPr lang="ru-RU" sz="1800" dirty="0"/>
+              <a:t>возможность запуска и завершения эфира; </a:t>
+            </a:r>
+          </a:p>
+          <a:p>
+            <a:pPr marL="285750" indent="-285750">
+              <a:buFont typeface="Arial" panose="020B0604020202020204" pitchFamily="34" charset="0"/>
+              <a:buChar char="•"/>
             </a:pPr>
-            <a:endParaRPr lang="en-US" sz="1800" dirty="0">
-              <a:effectLst/>
-              <a:latin typeface="Calibri" panose="020F0502020204030204" pitchFamily="34" charset="0"/>
-              <a:ea typeface="Calibri" panose="020F0502020204030204" pitchFamily="34" charset="0"/>
-              <a:cs typeface="Times New Roman" panose="02020603050405020304" pitchFamily="18" charset="0"/>
-            </a:endParaRPr>
-          </a:p>
-          <a:p>
-            <a:pPr>
-              <a:lnSpc>
-                <a:spcPct val="107000"/>
-              </a:lnSpc>
-              <a:spcAft>
-                <a:spcPts val="800"/>
-              </a:spcAft>
-              <a:tabLst>
-                <a:tab pos="2125980" algn="l"/>
-              </a:tabLst>
+            <a:r>
+              <a:rPr lang="ru-RU" sz="1800" dirty="0"/>
+              <a:t>привязку эфира к конкретному курсу или модулю; </a:t>
+            </a:r>
+          </a:p>
+          <a:p>
+            <a:pPr marL="285750" indent="-285750">
+              <a:buFont typeface="Arial" panose="020B0604020202020204" pitchFamily="34" charset="0"/>
+              <a:buChar char="•"/>
             </a:pPr>
             <a:r>
-              <a:rPr lang="ru-RU" sz="1800" dirty="0">
-                <a:effectLst/>
-                <a:latin typeface="Times New Roman" panose="02020603050405020304" pitchFamily="18" charset="0"/>
-                <a:ea typeface="Calibri" panose="020F0502020204030204" pitchFamily="34" charset="0"/>
-                <a:cs typeface="Times New Roman" panose="02020603050405020304" pitchFamily="18" charset="0"/>
-              </a:rPr>
-              <a:t>Проекционные матрицы играют ключевую роль в компьютерной графике и виртуальной реальности, включая фреймворк A-Frame. Они отвечают за преобразование трёхмерных (3D) координат объектов в двухмерные (2D) координаты экрана, что позволяет отображать 3D-сцены на 2D-устройствах, таких как мониторы или VR-гарнитуры.</a:t>
-            </a:r>
-          </a:p>
-          <a:p>
-            <a:pPr>
-              <a:lnSpc>
-                <a:spcPct val="107000"/>
-              </a:lnSpc>
-              <a:spcAft>
-                <a:spcPts val="800"/>
-              </a:spcAft>
-              <a:tabLst>
-                <a:tab pos="2125980" algn="l"/>
-              </a:tabLst>
+              <a:rPr lang="ru-RU" sz="1800" dirty="0"/>
+              <a:t>уведомление пользователей о начале трансляции; </a:t>
+            </a:r>
+          </a:p>
+          <a:p>
+            <a:pPr marL="285750" indent="-285750">
+              <a:buFont typeface="Arial" panose="020B0604020202020204" pitchFamily="34" charset="0"/>
+              <a:buChar char="•"/>
             </a:pPr>
-            <a:endParaRPr lang="en-US" sz="1800" dirty="0">
-              <a:effectLst/>
-              <a:latin typeface="Calibri" panose="020F0502020204030204" pitchFamily="34" charset="0"/>
-              <a:ea typeface="Calibri" panose="020F0502020204030204" pitchFamily="34" charset="0"/>
-              <a:cs typeface="Times New Roman" panose="02020603050405020304" pitchFamily="18" charset="0"/>
-            </a:endParaRPr>
-          </a:p>
-          <a:p>
-            <a:pPr>
-              <a:lnSpc>
-                <a:spcPct val="107000"/>
-              </a:lnSpc>
-              <a:spcAft>
-                <a:spcPts val="800"/>
-              </a:spcAft>
-              <a:tabLst>
-                <a:tab pos="2125980" algn="l"/>
-              </a:tabLst>
+            <a:r>
+              <a:rPr lang="ru-RU" sz="1800" dirty="0"/>
+              <a:t>поддержку взаимодействия участников через чат; </a:t>
+            </a:r>
+          </a:p>
+          <a:p>
+            <a:pPr marL="285750" indent="-285750">
+              <a:buFont typeface="Arial" panose="020B0604020202020204" pitchFamily="34" charset="0"/>
+              <a:buChar char="•"/>
             </a:pPr>
             <a:r>
-              <a:rPr lang="ru-RU" sz="1800" dirty="0">
-                <a:effectLst/>
-                <a:latin typeface="Times New Roman" panose="02020603050405020304" pitchFamily="18" charset="0"/>
-                <a:ea typeface="Calibri" panose="020F0502020204030204" pitchFamily="34" charset="0"/>
-                <a:cs typeface="Times New Roman" panose="02020603050405020304" pitchFamily="18" charset="0"/>
-              </a:rPr>
-              <a:t>Основные задачи проекционных матриц:</a:t>
-            </a:r>
-            <a:endParaRPr lang="en-US" sz="1800" dirty="0">
-              <a:effectLst/>
-              <a:latin typeface="Calibri" panose="020F0502020204030204" pitchFamily="34" charset="0"/>
-              <a:ea typeface="Calibri" panose="020F0502020204030204" pitchFamily="34" charset="0"/>
-              <a:cs typeface="Times New Roman" panose="02020603050405020304" pitchFamily="18" charset="0"/>
-            </a:endParaRPr>
-          </a:p>
-          <a:p>
-            <a:pPr marL="342900" lvl="0" indent="-342900">
-              <a:lnSpc>
-                <a:spcPct val="107000"/>
-              </a:lnSpc>
-              <a:buFont typeface="Symbol" panose="05050102010706020507" pitchFamily="18" charset="2"/>
-              <a:buChar char=""/>
-              <a:tabLst>
-                <a:tab pos="2125980" algn="l"/>
-              </a:tabLst>
-            </a:pPr>
-            <a:r>
-              <a:rPr lang="ru-RU" sz="1800" dirty="0">
-                <a:effectLst/>
-                <a:latin typeface="Times New Roman" panose="02020603050405020304" pitchFamily="18" charset="0"/>
-                <a:ea typeface="Calibri" panose="020F0502020204030204" pitchFamily="34" charset="0"/>
-                <a:cs typeface="Times New Roman" panose="02020603050405020304" pitchFamily="18" charset="0"/>
-              </a:rPr>
-              <a:t>Создание перспективы</a:t>
-            </a:r>
-            <a:endParaRPr lang="en-US" sz="1800" dirty="0">
-              <a:effectLst/>
-              <a:latin typeface="Calibri" panose="020F0502020204030204" pitchFamily="34" charset="0"/>
-              <a:ea typeface="Calibri" panose="020F0502020204030204" pitchFamily="34" charset="0"/>
-              <a:cs typeface="Times New Roman" panose="02020603050405020304" pitchFamily="18" charset="0"/>
-            </a:endParaRPr>
-          </a:p>
-          <a:p>
-            <a:pPr marL="342900" lvl="0" indent="-342900">
-              <a:lnSpc>
-                <a:spcPct val="107000"/>
-              </a:lnSpc>
-              <a:buFont typeface="Symbol" panose="05050102010706020507" pitchFamily="18" charset="2"/>
-              <a:buChar char=""/>
-              <a:tabLst>
-                <a:tab pos="2125980" algn="l"/>
-              </a:tabLst>
-            </a:pPr>
-            <a:r>
-              <a:rPr lang="ru-RU" sz="1800" dirty="0">
-                <a:effectLst/>
-                <a:latin typeface="Times New Roman" panose="02020603050405020304" pitchFamily="18" charset="0"/>
-                <a:ea typeface="Calibri" panose="020F0502020204030204" pitchFamily="34" charset="0"/>
-                <a:cs typeface="Times New Roman" panose="02020603050405020304" pitchFamily="18" charset="0"/>
-              </a:rPr>
-              <a:t>Определение поля зрения (FOV): Контроль за углом обзора камеры, влияющим на восприятие сцены.</a:t>
-            </a:r>
-            <a:endParaRPr lang="en-US" sz="1800" dirty="0">
-              <a:effectLst/>
-              <a:latin typeface="Calibri" panose="020F0502020204030204" pitchFamily="34" charset="0"/>
-              <a:ea typeface="Calibri" panose="020F0502020204030204" pitchFamily="34" charset="0"/>
-              <a:cs typeface="Times New Roman" panose="02020603050405020304" pitchFamily="18" charset="0"/>
-            </a:endParaRPr>
-          </a:p>
-          <a:p>
-            <a:pPr marL="342900" lvl="0" indent="-342900">
-              <a:lnSpc>
-                <a:spcPct val="107000"/>
-              </a:lnSpc>
-              <a:buFont typeface="Symbol" panose="05050102010706020507" pitchFamily="18" charset="2"/>
-              <a:buChar char=""/>
-              <a:tabLst>
-                <a:tab pos="2125980" algn="l"/>
-              </a:tabLst>
-            </a:pPr>
-            <a:r>
-              <a:rPr lang="ru-RU" sz="1800" dirty="0">
-                <a:effectLst/>
-                <a:latin typeface="Times New Roman" panose="02020603050405020304" pitchFamily="18" charset="0"/>
-                <a:ea typeface="Calibri" panose="020F0502020204030204" pitchFamily="34" charset="0"/>
-                <a:cs typeface="Times New Roman" panose="02020603050405020304" pitchFamily="18" charset="0"/>
-              </a:rPr>
-              <a:t>Управление аспектным соотношением</a:t>
-            </a:r>
-            <a:endParaRPr lang="en-US" sz="1800" dirty="0">
-              <a:effectLst/>
-              <a:latin typeface="Calibri" panose="020F0502020204030204" pitchFamily="34" charset="0"/>
-              <a:ea typeface="Calibri" panose="020F0502020204030204" pitchFamily="34" charset="0"/>
-              <a:cs typeface="Times New Roman" panose="02020603050405020304" pitchFamily="18" charset="0"/>
-            </a:endParaRPr>
-          </a:p>
-          <a:p>
-            <a:pPr marL="342900" lvl="0" indent="-342900">
-              <a:lnSpc>
-                <a:spcPct val="107000"/>
-              </a:lnSpc>
-              <a:spcAft>
-                <a:spcPts val="800"/>
-              </a:spcAft>
-              <a:buFont typeface="Symbol" panose="05050102010706020507" pitchFamily="18" charset="2"/>
-              <a:buChar char=""/>
-              <a:tabLst>
-                <a:tab pos="2125980" algn="l"/>
-              </a:tabLst>
-            </a:pPr>
-            <a:r>
-              <a:rPr lang="ru-RU" sz="1800" dirty="0">
-                <a:effectLst/>
-                <a:latin typeface="Times New Roman" panose="02020603050405020304" pitchFamily="18" charset="0"/>
-                <a:ea typeface="Calibri" panose="020F0502020204030204" pitchFamily="34" charset="0"/>
-                <a:cs typeface="Times New Roman" panose="02020603050405020304" pitchFamily="18" charset="0"/>
-              </a:rPr>
-              <a:t>Настройка ближней и дальней плоскостей отсечения: Определение диапазона расстояний, в котором объекты будут отображаться, что влияет на производительность и визуальное качество.</a:t>
-            </a:r>
-          </a:p>
-          <a:p>
-            <a:pPr marL="342900" lvl="0" indent="-342900">
-              <a:lnSpc>
-                <a:spcPct val="107000"/>
-              </a:lnSpc>
-              <a:spcAft>
-                <a:spcPts val="800"/>
-              </a:spcAft>
-              <a:buFont typeface="Symbol" panose="05050102010706020507" pitchFamily="18" charset="2"/>
-              <a:buChar char=""/>
-              <a:tabLst>
-                <a:tab pos="2125980" algn="l"/>
-              </a:tabLst>
-            </a:pPr>
-            <a:endParaRPr lang="ru-RU" sz="1800" dirty="0">
-              <a:effectLst/>
-              <a:latin typeface="Times New Roman" panose="02020603050405020304" pitchFamily="18" charset="0"/>
-              <a:ea typeface="Calibri" panose="020F0502020204030204" pitchFamily="34" charset="0"/>
-              <a:cs typeface="Times New Roman" panose="02020603050405020304" pitchFamily="18" charset="0"/>
-            </a:endParaRPr>
-          </a:p>
-          <a:p>
-            <a:pPr>
-              <a:lnSpc>
-                <a:spcPct val="107000"/>
-              </a:lnSpc>
-              <a:spcAft>
-                <a:spcPts val="800"/>
-              </a:spcAft>
-              <a:tabLst>
-                <a:tab pos="2125980" algn="l"/>
-              </a:tabLst>
-            </a:pPr>
-            <a:r>
-              <a:rPr lang="ru-RU" sz="1800" b="1" dirty="0">
-                <a:effectLst/>
-                <a:latin typeface="Times New Roman" panose="02020603050405020304" pitchFamily="18" charset="0"/>
-                <a:ea typeface="Calibri" panose="020F0502020204030204" pitchFamily="34" charset="0"/>
-                <a:cs typeface="Times New Roman" panose="02020603050405020304" pitchFamily="18" charset="0"/>
-              </a:rPr>
-              <a:t>Компоненты матрицы:</a:t>
-            </a:r>
-            <a:endParaRPr lang="en-US" sz="1800" b="1" dirty="0">
-              <a:effectLst/>
-              <a:latin typeface="Calibri" panose="020F0502020204030204" pitchFamily="34" charset="0"/>
-              <a:ea typeface="Calibri" panose="020F0502020204030204" pitchFamily="34" charset="0"/>
-              <a:cs typeface="Times New Roman" panose="02020603050405020304" pitchFamily="18" charset="0"/>
-            </a:endParaRPr>
-          </a:p>
-          <a:p>
-            <a:pPr>
-              <a:lnSpc>
-                <a:spcPct val="107000"/>
-              </a:lnSpc>
-              <a:spcAft>
-                <a:spcPts val="800"/>
-              </a:spcAft>
-              <a:tabLst>
-                <a:tab pos="2125980" algn="l"/>
-              </a:tabLst>
-            </a:pPr>
-            <a:r>
-              <a:rPr lang="ru-RU" sz="1800" dirty="0">
-                <a:effectLst/>
-                <a:latin typeface="Times New Roman" panose="02020603050405020304" pitchFamily="18" charset="0"/>
-                <a:ea typeface="Calibri" panose="020F0502020204030204" pitchFamily="34" charset="0"/>
-                <a:cs typeface="Times New Roman" panose="02020603050405020304" pitchFamily="18" charset="0"/>
-              </a:rPr>
-              <a:t>Первая строка: Контролирует масштабирование по оси X с учётом поля зрения и аспектного соотношения.</a:t>
-            </a:r>
-            <a:endParaRPr lang="en-US" sz="1800" dirty="0">
-              <a:effectLst/>
-              <a:latin typeface="Calibri" panose="020F0502020204030204" pitchFamily="34" charset="0"/>
-              <a:ea typeface="Calibri" panose="020F0502020204030204" pitchFamily="34" charset="0"/>
-              <a:cs typeface="Times New Roman" panose="02020603050405020304" pitchFamily="18" charset="0"/>
-            </a:endParaRPr>
-          </a:p>
-          <a:p>
-            <a:pPr>
-              <a:lnSpc>
-                <a:spcPct val="107000"/>
-              </a:lnSpc>
-              <a:spcAft>
-                <a:spcPts val="800"/>
-              </a:spcAft>
-              <a:tabLst>
-                <a:tab pos="2125980" algn="l"/>
-              </a:tabLst>
-            </a:pPr>
-            <a:r>
-              <a:rPr lang="ru-RU" sz="1800" dirty="0">
-                <a:effectLst/>
-                <a:latin typeface="Times New Roman" panose="02020603050405020304" pitchFamily="18" charset="0"/>
-                <a:ea typeface="Calibri" panose="020F0502020204030204" pitchFamily="34" charset="0"/>
-                <a:cs typeface="Times New Roman" panose="02020603050405020304" pitchFamily="18" charset="0"/>
-              </a:rPr>
-              <a:t>Вторая строка: Контролирует масштабирование по оси Y с учётом поля зрения.</a:t>
-            </a:r>
-            <a:endParaRPr lang="en-US" sz="1800" dirty="0">
-              <a:effectLst/>
-              <a:latin typeface="Calibri" panose="020F0502020204030204" pitchFamily="34" charset="0"/>
-              <a:ea typeface="Calibri" panose="020F0502020204030204" pitchFamily="34" charset="0"/>
-              <a:cs typeface="Times New Roman" panose="02020603050405020304" pitchFamily="18" charset="0"/>
-            </a:endParaRPr>
-          </a:p>
-          <a:p>
-            <a:pPr>
-              <a:lnSpc>
-                <a:spcPct val="107000"/>
-              </a:lnSpc>
-              <a:spcAft>
-                <a:spcPts val="800"/>
-              </a:spcAft>
-              <a:tabLst>
-                <a:tab pos="2125980" algn="l"/>
-              </a:tabLst>
-            </a:pPr>
-            <a:r>
-              <a:rPr lang="ru-RU" sz="1800" dirty="0">
-                <a:effectLst/>
-                <a:latin typeface="Times New Roman" panose="02020603050405020304" pitchFamily="18" charset="0"/>
-                <a:ea typeface="Calibri" panose="020F0502020204030204" pitchFamily="34" charset="0"/>
-                <a:cs typeface="Times New Roman" panose="02020603050405020304" pitchFamily="18" charset="0"/>
-              </a:rPr>
-              <a:t>Третья строка: Определяет, как глубина (ось Z) преобразуется для управления видимостью объектов.</a:t>
-            </a:r>
-            <a:endParaRPr lang="en-US" sz="1800" dirty="0">
-              <a:effectLst/>
-              <a:latin typeface="Calibri" panose="020F0502020204030204" pitchFamily="34" charset="0"/>
-              <a:ea typeface="Calibri" panose="020F0502020204030204" pitchFamily="34" charset="0"/>
-              <a:cs typeface="Times New Roman" panose="02020603050405020304" pitchFamily="18" charset="0"/>
-            </a:endParaRPr>
-          </a:p>
-          <a:p>
-            <a:pPr>
-              <a:lnSpc>
-                <a:spcPct val="107000"/>
-              </a:lnSpc>
-              <a:spcAft>
-                <a:spcPts val="800"/>
-              </a:spcAft>
-              <a:tabLst>
-                <a:tab pos="2125980" algn="l"/>
-              </a:tabLst>
-            </a:pPr>
-            <a:r>
-              <a:rPr lang="ru-RU" sz="1800" dirty="0">
-                <a:effectLst/>
-                <a:latin typeface="Times New Roman" panose="02020603050405020304" pitchFamily="18" charset="0"/>
-                <a:ea typeface="Calibri" panose="020F0502020204030204" pitchFamily="34" charset="0"/>
-                <a:cs typeface="Times New Roman" panose="02020603050405020304" pitchFamily="18" charset="0"/>
-              </a:rPr>
-              <a:t>Четвёртая строка: Используется для проектирования перспективы, создавая зависимость координаты Z от координаты W.</a:t>
-            </a:r>
-            <a:endParaRPr lang="en-US" sz="1800" dirty="0">
-              <a:effectLst/>
-              <a:latin typeface="Calibri" panose="020F0502020204030204" pitchFamily="34" charset="0"/>
-              <a:ea typeface="Calibri" panose="020F0502020204030204" pitchFamily="34" charset="0"/>
-              <a:cs typeface="Times New Roman" panose="02020603050405020304" pitchFamily="18" charset="0"/>
-            </a:endParaRPr>
-          </a:p>
-          <a:p>
-            <a:pPr marL="0" lvl="0" indent="0">
-              <a:lnSpc>
-                <a:spcPct val="107000"/>
-              </a:lnSpc>
-              <a:spcAft>
-                <a:spcPts val="800"/>
-              </a:spcAft>
-              <a:buFont typeface="Symbol" panose="05050102010706020507" pitchFamily="18" charset="2"/>
-              <a:buNone/>
-              <a:tabLst>
-                <a:tab pos="2125980" algn="l"/>
-              </a:tabLst>
-            </a:pPr>
-            <a:endParaRPr lang="en-US" sz="1800" dirty="0">
-              <a:effectLst/>
-              <a:latin typeface="Calibri" panose="020F0502020204030204" pitchFamily="34" charset="0"/>
-              <a:ea typeface="Calibri" panose="020F0502020204030204" pitchFamily="34" charset="0"/>
-              <a:cs typeface="Times New Roman" panose="02020603050405020304" pitchFamily="18" charset="0"/>
-            </a:endParaRPr>
-          </a:p>
-          <a:p>
-            <a:endParaRPr lang="en-US" dirty="0"/>
+              <a:rPr lang="ru-RU" sz="1800" dirty="0"/>
+              <a:t>дальнейшее хранение или публикацию записи эфира. </a:t>
+            </a:r>
+          </a:p>
+          <a:p>
+            <a:r>
+              <a:rPr lang="ru-RU" sz="1800" dirty="0"/>
+              <a:t>Таким образом, эфир в системе рассматривается не как отдельный видеопоток, а как комплексный объект, связанный с контентом, расписанием и пользовательским взаимодействием.</a:t>
+            </a:r>
           </a:p>
         </p:txBody>
       </p:sp>
@@ -1135,9 +800,14 @@
           <a:p>
             <a:r>
               <a:rPr lang="ru-RU" dirty="0"/>
-              <a:t>Рассказать про видеоплеер</a:t>
-            </a:r>
-            <a:endParaRPr lang="en-US" dirty="0"/>
+              <a:t>На данном слайде показан видеоплеер, используемый в платформе.</a:t>
+            </a:r>
+          </a:p>
+          <a:p>
+            <a:r>
+              <a:rPr lang="ru-RU" dirty="0"/>
+              <a:t>Видеоплеер является важной частью пользовательского интерфейса, так как именно через него осуществляется основное потребление учебного видеоконтента.</a:t>
+            </a:r>
           </a:p>
         </p:txBody>
       </p:sp>
@@ -1241,9 +911,191 @@
           <a:p>
             <a:r>
               <a:rPr lang="ru-RU" dirty="0"/>
-              <a:t>Рассказать про видеоплеер</a:t>
-            </a:r>
-            <a:endParaRPr lang="en-US" dirty="0"/>
+              <a:t>На этом слайде представлены результаты исследования, связанного с кодированием видео.</a:t>
+            </a:r>
+          </a:p>
+          <a:p>
+            <a:r>
+              <a:rPr lang="ru-RU" dirty="0"/>
+              <a:t>В рамках работы было проведено сравнение нескольких кодеков и параметров сжатия для одного и того же видеоматериала.</a:t>
+            </a:r>
+            <a:br>
+              <a:rPr lang="ru-RU" dirty="0"/>
+            </a:br>
+            <a:r>
+              <a:rPr lang="ru-RU" dirty="0"/>
+              <a:t>Целью этого исследования являлось определение компромисса между:</a:t>
+            </a:r>
+          </a:p>
+          <a:p>
+            <a:r>
+              <a:rPr lang="ru-RU" dirty="0"/>
+              <a:t>размером итогового файла, </a:t>
+            </a:r>
+          </a:p>
+          <a:p>
+            <a:r>
+              <a:rPr lang="ru-RU" dirty="0"/>
+              <a:t>качеством изображения, </a:t>
+            </a:r>
+          </a:p>
+          <a:p>
+            <a:r>
+              <a:rPr lang="ru-RU" dirty="0"/>
+              <a:t>и временем кодирования. </a:t>
+            </a:r>
+          </a:p>
+          <a:p>
+            <a:r>
+              <a:rPr lang="ru-RU" dirty="0"/>
+              <a:t>Сравнивались различные варианты кодирования, а оценка выполнялась как по размеру получающихся файлов, так и по объективным метрикам качества, таким как </a:t>
+            </a:r>
+            <a:r>
+              <a:rPr lang="ru-RU" b="1" dirty="0"/>
+              <a:t>PSNR</a:t>
+            </a:r>
+            <a:r>
+              <a:rPr lang="ru-RU" dirty="0"/>
+              <a:t> и </a:t>
+            </a:r>
+            <a:r>
+              <a:rPr lang="ru-RU" b="1" dirty="0"/>
+              <a:t>SSIM</a:t>
+            </a:r>
+            <a:r>
+              <a:rPr lang="ru-RU" dirty="0"/>
+              <a:t>, а также по времени обработки.</a:t>
+            </a:r>
+          </a:p>
+          <a:p>
+            <a:r>
+              <a:rPr lang="ru-RU" dirty="0"/>
+              <a:t>Результаты показали, что выбор кодека должен учитывать не только качество, но и вычислительные затраты, поскольку для образовательной платформы важны как хранение видео, так и скорость публикации и обработки контента.</a:t>
+            </a:r>
+          </a:p>
+          <a:p>
+            <a:endParaRPr lang="ru-RU" dirty="0"/>
+          </a:p>
+          <a:p>
+            <a:r>
+              <a:rPr lang="ru-RU" b="1" dirty="0"/>
+              <a:t>PSNR</a:t>
+            </a:r>
+            <a:r>
+              <a:rPr lang="ru-RU" dirty="0"/>
+              <a:t> — это </a:t>
+            </a:r>
+            <a:r>
+              <a:rPr lang="ru-RU" b="1" dirty="0" err="1"/>
+              <a:t>Peak</a:t>
+            </a:r>
+            <a:r>
+              <a:rPr lang="ru-RU" b="1" dirty="0"/>
+              <a:t> </a:t>
+            </a:r>
+            <a:r>
+              <a:rPr lang="ru-RU" b="1" dirty="0" err="1"/>
+              <a:t>Signal-to-Noise</a:t>
+            </a:r>
+            <a:r>
+              <a:rPr lang="ru-RU" b="1" dirty="0"/>
+              <a:t> </a:t>
+            </a:r>
+            <a:r>
+              <a:rPr lang="ru-RU" b="1" dirty="0" err="1"/>
+              <a:t>Ratio</a:t>
+            </a:r>
+            <a:r>
+              <a:rPr lang="ru-RU" dirty="0"/>
+              <a:t>, по-русски обычно: (чем выше тем лучше)</a:t>
+            </a:r>
+            <a:br>
+              <a:rPr lang="ru-RU" dirty="0"/>
+            </a:br>
+            <a:r>
+              <a:rPr lang="ru-RU" b="1" dirty="0"/>
+              <a:t>пиковое отношение сигнала к шуму</a:t>
+            </a:r>
+            <a:r>
+              <a:rPr lang="ru-RU" dirty="0"/>
+              <a:t>.</a:t>
+            </a:r>
+          </a:p>
+          <a:p>
+            <a:r>
+              <a:rPr lang="ru-RU" dirty="0"/>
+              <a:t>По сути, эта метрика показывает, </a:t>
+            </a:r>
+            <a:r>
+              <a:rPr lang="ru-RU" b="1" dirty="0"/>
+              <a:t>насколько сильно пиксели сжатого изображения отличаются от исходных</a:t>
+            </a:r>
+            <a:r>
+              <a:rPr lang="ru-RU" dirty="0"/>
+              <a:t>.</a:t>
+            </a:r>
+          </a:p>
+          <a:p>
+            <a:endParaRPr lang="ru-RU" dirty="0"/>
+          </a:p>
+          <a:p>
+            <a:r>
+              <a:rPr lang="ru-RU" b="1" dirty="0"/>
+              <a:t>SSIM</a:t>
+            </a:r>
+            <a:r>
+              <a:rPr lang="ru-RU" dirty="0"/>
+              <a:t> — это </a:t>
+            </a:r>
+            <a:r>
+              <a:rPr lang="ru-RU" b="1" dirty="0" err="1"/>
+              <a:t>Structural</a:t>
+            </a:r>
+            <a:r>
+              <a:rPr lang="ru-RU" b="1" dirty="0"/>
+              <a:t> </a:t>
+            </a:r>
+            <a:r>
+              <a:rPr lang="ru-RU" b="1" dirty="0" err="1"/>
+              <a:t>Similarity</a:t>
+            </a:r>
+            <a:r>
+              <a:rPr lang="ru-RU" b="1" dirty="0"/>
+              <a:t> Index</a:t>
+            </a:r>
+            <a:r>
+              <a:rPr lang="ru-RU" dirty="0"/>
+              <a:t>, (от 0 до 1, где 1 - исходное)</a:t>
+            </a:r>
+            <a:br>
+              <a:rPr lang="ru-RU" dirty="0"/>
+            </a:br>
+            <a:r>
+              <a:rPr lang="ru-RU" dirty="0"/>
+              <a:t>по-русски: </a:t>
+            </a:r>
+            <a:r>
+              <a:rPr lang="ru-RU" b="1" dirty="0"/>
+              <a:t>индекс структурного сходства</a:t>
+            </a:r>
+            <a:r>
+              <a:rPr lang="ru-RU" dirty="0"/>
+              <a:t>.</a:t>
+            </a:r>
+          </a:p>
+          <a:p>
+            <a:r>
+              <a:rPr lang="ru-RU" dirty="0"/>
+              <a:t>Эта метрика оценивает не просто разницу по пикселям, а </a:t>
+            </a:r>
+            <a:r>
+              <a:rPr lang="ru-RU" b="1" dirty="0"/>
+              <a:t>насколько похожа структура изображения</a:t>
+            </a:r>
+            <a:r>
+              <a:rPr lang="ru-RU" dirty="0"/>
+              <a:t>:</a:t>
+            </a:r>
           </a:p>
         </p:txBody>
       </p:sp>
@@ -1340,24 +1192,10 @@
             <a:endParaRPr lang="ru-RU" dirty="0"/>
           </a:p>
           <a:p>
-            <a:pPr marL="0" marR="0" lvl="0" indent="0" algn="l" defTabSz="914400" rtl="0" eaLnBrk="1" fontAlgn="auto" latinLnBrk="0" hangingPunct="1">
-              <a:lnSpc>
-                <a:spcPct val="100000"/>
-              </a:lnSpc>
-              <a:spcBef>
-                <a:spcPts val="0"/>
-              </a:spcBef>
-              <a:spcAft>
-                <a:spcPts val="0"/>
-              </a:spcAft>
-              <a:buClrTx/>
-              <a:buSzTx/>
-              <a:buFontTx/>
-              <a:buNone/>
-              <a:tabLst/>
-              <a:defRPr/>
-            </a:pPr>
-            <a:endParaRPr lang="en-US" dirty="0"/>
+            <a:r>
+              <a:rPr lang="ru-RU" dirty="0"/>
+              <a:t>На данном слайде представлена демонстрация работы разработанной платформы.</a:t>
+            </a:r>
           </a:p>
         </p:txBody>
       </p:sp>
@@ -1443,24 +1281,19 @@
           <a:p>
             <a:r>
               <a:rPr lang="ru-RU" dirty="0"/>
-              <a:t>Таким образом, было разработано веб-приложение, сочетающее в себе </a:t>
-            </a:r>
-            <a:r>
-              <a:rPr lang="en-US" dirty="0"/>
-              <a:t>AR </a:t>
-            </a:r>
-            <a:r>
-              <a:rPr lang="ru-RU" dirty="0"/>
-              <a:t>и </a:t>
-            </a:r>
-            <a:r>
-              <a:rPr lang="en-US" dirty="0"/>
-              <a:t>AI </a:t>
-            </a:r>
-            <a:r>
-              <a:rPr lang="ru-RU" dirty="0"/>
-              <a:t>функционал для художников.</a:t>
-            </a:r>
+              <a:t>Таким образом, было разработано веб-приложение, </a:t>
+            </a:r>
+            <a:r>
+              <a:rPr lang="ru-RU" sz="1200" dirty="0">
+                <a:solidFill>
+                  <a:schemeClr val="tx1">
+                    <a:alpha val="70000"/>
+                  </a:schemeClr>
+                </a:solidFill>
+              </a:rPr>
+              <a:t>реализующее безопасную цифровую образовательную платформу для онлайн-курсов с гибким функционалом.</a:t>
+            </a:r>
+            <a:endParaRPr lang="ru-RU" dirty="0"/>
           </a:p>
           <a:p>
             <a:endParaRPr lang="ru-RU" dirty="0"/>
@@ -1472,172 +1305,113 @@
             </a:r>
           </a:p>
           <a:p>
-            <a:pPr marL="342900" lvl="0" indent="-342900" algn="just">
-              <a:lnSpc>
-                <a:spcPct val="150000"/>
-              </a:lnSpc>
-              <a:spcBef>
-                <a:spcPts val="600"/>
-              </a:spcBef>
-              <a:spcAft>
-                <a:spcPts val="600"/>
-              </a:spcAft>
-              <a:buFont typeface="+mj-lt"/>
-              <a:buAutoNum type="arabicPeriod"/>
+            <a:pPr algn="just"/>
+            <a:r>
+              <a:rPr lang="ru-RU" sz="1200" dirty="0">
+                <a:solidFill>
+                  <a:schemeClr val="tx1">
+                    <a:alpha val="70000"/>
+                  </a:schemeClr>
+                </a:solidFill>
+              </a:rPr>
+              <a:t>1.         Проведён анализ современных </a:t>
+            </a:r>
+            <a:r>
+              <a:rPr lang="ru-RU" dirty="0"/>
+              <a:t>образовательных платформ и их требований</a:t>
+            </a:r>
+            <a:r>
+              <a:rPr lang="ru-RU" sz="1200" dirty="0">
+                <a:solidFill>
+                  <a:schemeClr val="tx1">
+                    <a:alpha val="70000"/>
+                  </a:schemeClr>
+                </a:solidFill>
+              </a:rPr>
+              <a:t>;</a:t>
+            </a:r>
+          </a:p>
+          <a:p>
+            <a:pPr marL="457200" indent="-457200" algn="just">
+              <a:buAutoNum type="arabicPeriod" startAt="2"/>
             </a:pPr>
             <a:r>
+              <a:rPr lang="ru-RU" dirty="0"/>
+              <a:t>Исследованы подходы к аутентификации, авторизации и управлению доступом</a:t>
+            </a:r>
+            <a:r>
               <a:rPr lang="ru-RU" sz="1200" dirty="0">
-                <a:effectLst/>
-                <a:latin typeface="Times New Roman" panose="02020603050405020304" pitchFamily="18" charset="0"/>
-                <a:ea typeface="Times New Roman" panose="02020603050405020304" pitchFamily="18" charset="0"/>
+                <a:solidFill>
+                  <a:schemeClr val="tx1">
+                    <a:alpha val="70000"/>
+                  </a:schemeClr>
+                </a:solidFill>
               </a:rPr>
-              <a:t>Проведен обзор существующих технологий в области AR, AI и их применения в искусстве;</a:t>
-            </a:r>
-            <a:endParaRPr lang="en-US" sz="1200" dirty="0">
-              <a:effectLst/>
-              <a:latin typeface="Times New Roman" panose="02020603050405020304" pitchFamily="18" charset="0"/>
-              <a:ea typeface="Times New Roman" panose="02020603050405020304" pitchFamily="18" charset="0"/>
-            </a:endParaRPr>
-          </a:p>
-          <a:p>
-            <a:pPr marL="342900" lvl="0" indent="-342900" algn="just">
-              <a:lnSpc>
-                <a:spcPct val="150000"/>
-              </a:lnSpc>
-              <a:spcBef>
-                <a:spcPts val="600"/>
-              </a:spcBef>
-              <a:spcAft>
-                <a:spcPts val="600"/>
-              </a:spcAft>
-              <a:buFont typeface="+mj-lt"/>
-              <a:buAutoNum type="arabicPeriod"/>
+              <a:t>;</a:t>
+            </a:r>
+          </a:p>
+          <a:p>
+            <a:pPr marL="457200" indent="-457200" algn="just">
+              <a:buFontTx/>
+              <a:buAutoNum type="arabicPeriod" startAt="2"/>
             </a:pPr>
             <a:r>
               <a:rPr lang="ru-RU" sz="1200" dirty="0">
-                <a:effectLst/>
-                <a:latin typeface="Times New Roman" panose="02020603050405020304" pitchFamily="18" charset="0"/>
-                <a:ea typeface="Times New Roman" panose="02020603050405020304" pitchFamily="18" charset="0"/>
+                <a:solidFill>
+                  <a:schemeClr val="tx1">
+                    <a:alpha val="70000"/>
+                  </a:schemeClr>
+                </a:solidFill>
               </a:rPr>
-              <a:t>Разработан пользовательский интерфейс (UI), учитывающий как AR, так и AI-функциональность;</a:t>
-            </a:r>
-            <a:endParaRPr lang="en-US" sz="1200" dirty="0">
-              <a:effectLst/>
-              <a:latin typeface="Times New Roman" panose="02020603050405020304" pitchFamily="18" charset="0"/>
-              <a:ea typeface="Times New Roman" panose="02020603050405020304" pitchFamily="18" charset="0"/>
-            </a:endParaRPr>
-          </a:p>
-          <a:p>
-            <a:pPr marL="342900" lvl="0" indent="-342900" algn="just">
-              <a:lnSpc>
-                <a:spcPct val="150000"/>
-              </a:lnSpc>
-              <a:spcBef>
-                <a:spcPts val="600"/>
-              </a:spcBef>
-              <a:spcAft>
-                <a:spcPts val="600"/>
-              </a:spcAft>
-              <a:buFont typeface="+mj-lt"/>
-              <a:buAutoNum type="arabicPeriod"/>
+              <a:t>Реализована собственная система авторизации и разграничения прав доступа.</a:t>
+            </a:r>
+          </a:p>
+          <a:p>
+            <a:pPr marL="457200" indent="-457200" algn="just">
+              <a:buAutoNum type="arabicPeriod" startAt="4"/>
             </a:pPr>
             <a:r>
               <a:rPr lang="ru-RU" sz="1200" dirty="0">
-                <a:effectLst/>
-                <a:latin typeface="Times New Roman" panose="02020603050405020304" pitchFamily="18" charset="0"/>
-                <a:ea typeface="Times New Roman" panose="02020603050405020304" pitchFamily="18" charset="0"/>
+                <a:solidFill>
+                  <a:schemeClr val="tx1">
+                    <a:alpha val="70000"/>
+                  </a:schemeClr>
+                </a:solidFill>
               </a:rPr>
-              <a:t>Интегрированы библиотеки и модули для реализации картографической части приложения;</a:t>
-            </a:r>
-            <a:endParaRPr lang="en-US" sz="1200" dirty="0">
-              <a:effectLst/>
-              <a:latin typeface="Times New Roman" panose="02020603050405020304" pitchFamily="18" charset="0"/>
-              <a:ea typeface="Times New Roman" panose="02020603050405020304" pitchFamily="18" charset="0"/>
-            </a:endParaRPr>
-          </a:p>
-          <a:p>
-            <a:pPr marL="342900" lvl="0" indent="-342900" algn="just">
-              <a:lnSpc>
-                <a:spcPct val="150000"/>
-              </a:lnSpc>
-              <a:spcBef>
-                <a:spcPts val="600"/>
-              </a:spcBef>
-              <a:spcAft>
-                <a:spcPts val="600"/>
-              </a:spcAft>
-              <a:buFont typeface="+mj-lt"/>
-              <a:buAutoNum type="arabicPeriod"/>
+              <a:t>Спроектирован и разработан основной функционал цифровой платформы;</a:t>
+            </a:r>
+          </a:p>
+          <a:p>
+            <a:pPr marL="457200" indent="-457200" algn="just">
+              <a:buFontTx/>
+              <a:buAutoNum type="arabicPeriod" startAt="4"/>
             </a:pPr>
             <a:r>
               <a:rPr lang="ru-RU" sz="1200" dirty="0">
-                <a:effectLst/>
-                <a:latin typeface="Times New Roman" panose="02020603050405020304" pitchFamily="18" charset="0"/>
-                <a:ea typeface="Times New Roman" panose="02020603050405020304" pitchFamily="18" charset="0"/>
+                <a:solidFill>
+                  <a:schemeClr val="tx1">
+                    <a:alpha val="70000"/>
+                  </a:schemeClr>
+                </a:solidFill>
               </a:rPr>
-              <a:t>Реализована работа GPT-ассистента, способного отвечать на запросы пользователей, используя заранее заданные профессиональные настройки;</a:t>
-            </a:r>
-            <a:endParaRPr lang="en-US" sz="1200" dirty="0">
-              <a:effectLst/>
-              <a:latin typeface="Times New Roman" panose="02020603050405020304" pitchFamily="18" charset="0"/>
-              <a:ea typeface="Times New Roman" panose="02020603050405020304" pitchFamily="18" charset="0"/>
-            </a:endParaRPr>
-          </a:p>
-          <a:p>
-            <a:pPr marL="342900" lvl="0" indent="-342900" algn="just">
-              <a:lnSpc>
-                <a:spcPct val="150000"/>
-              </a:lnSpc>
-              <a:spcBef>
-                <a:spcPts val="600"/>
-              </a:spcBef>
-              <a:spcAft>
-                <a:spcPts val="600"/>
-              </a:spcAft>
-              <a:buFont typeface="+mj-lt"/>
-              <a:buAutoNum type="arabicPeriod"/>
+              <a:t>Реализована интеграция библиотек и модулей для реализации обработки видео;</a:t>
+            </a:r>
+          </a:p>
+          <a:p>
+            <a:pPr marL="457200" indent="-457200" algn="just">
+              <a:buFontTx/>
+              <a:buAutoNum type="arabicPeriod" startAt="4"/>
             </a:pPr>
             <a:r>
               <a:rPr lang="ru-RU" sz="1200" dirty="0">
-                <a:effectLst/>
-                <a:latin typeface="Times New Roman" panose="02020603050405020304" pitchFamily="18" charset="0"/>
-                <a:ea typeface="Times New Roman" panose="02020603050405020304" pitchFamily="18" charset="0"/>
+                <a:solidFill>
+                  <a:schemeClr val="tx1">
+                    <a:alpha val="70000"/>
+                  </a:schemeClr>
+                </a:solidFill>
               </a:rPr>
-              <a:t>Разработаны методы взаимодействия пользователя с цифровым контентом в AR и AI-режиме;</a:t>
-            </a:r>
-            <a:endParaRPr lang="en-US" sz="1200" dirty="0">
-              <a:effectLst/>
-              <a:latin typeface="Times New Roman" panose="02020603050405020304" pitchFamily="18" charset="0"/>
-              <a:ea typeface="Times New Roman" panose="02020603050405020304" pitchFamily="18" charset="0"/>
-            </a:endParaRPr>
-          </a:p>
-          <a:p>
-            <a:pPr marL="342900" lvl="0" indent="-342900" algn="just">
-              <a:lnSpc>
-                <a:spcPct val="150000"/>
-              </a:lnSpc>
-              <a:spcBef>
-                <a:spcPts val="600"/>
-              </a:spcBef>
-              <a:spcAft>
-                <a:spcPts val="600"/>
-              </a:spcAft>
-              <a:buFont typeface="+mj-lt"/>
-              <a:buAutoNum type="arabicPeriod"/>
-            </a:pPr>
-            <a:r>
-              <a:rPr lang="ru-RU" sz="1200" dirty="0">
-                <a:effectLst/>
-                <a:latin typeface="Times New Roman" panose="02020603050405020304" pitchFamily="18" charset="0"/>
-                <a:ea typeface="Times New Roman" panose="02020603050405020304" pitchFamily="18" charset="0"/>
-              </a:rPr>
-              <a:t>Проведен обзор существующих систем управления подписками и выбрана одна из них для внедрения в приложение.</a:t>
-            </a:r>
-            <a:endParaRPr lang="en-US" sz="1200" dirty="0">
-              <a:effectLst/>
-              <a:latin typeface="Times New Roman" panose="02020603050405020304" pitchFamily="18" charset="0"/>
-              <a:ea typeface="Times New Roman" panose="02020603050405020304" pitchFamily="18" charset="0"/>
-            </a:endParaRPr>
+              <a:t>Спроектирован и реализован пользовательский интерфейс</a:t>
+            </a:r>
           </a:p>
           <a:p>
             <a:endParaRPr lang="en-US" dirty="0"/>
@@ -1812,93 +1586,47 @@
           <a:bodyPr/>
           <a:lstStyle/>
           <a:p>
-            <a:pPr rtl="0"/>
             <a:r>
               <a:rPr lang="ru-RU" dirty="0"/>
-              <a:t>В современном мире технологии дополненной реальности (AR) и искусственного интеллекта (AI) находят широкое применение в различных сферах, включая искусство. Виртуальные галереи становятся эффективным инструментом, обеспечивающим доступ к произведениям искусства независимо от географического положения, что делает их популярными среди художников и зрителей.</a:t>
-            </a:r>
-          </a:p>
-          <a:p>
-            <a:pPr rtl="0"/>
-            <a:endParaRPr lang="ru-RU" dirty="0"/>
-          </a:p>
-          <a:p>
-            <a:pPr rtl="0"/>
+              <a:t>Актуальность работы обусловлена сразу несколькими факторами.</a:t>
+            </a:r>
+          </a:p>
+          <a:p>
+            <a:pPr marL="0" indent="0">
+              <a:buFont typeface="Arial" panose="020B0604020202020204" pitchFamily="34" charset="0"/>
+              <a:buNone/>
+            </a:pPr>
             <a:r>
               <a:rPr lang="ru-RU" dirty="0"/>
-              <a:t>Актуальность исследования обусловлена следующими факторами:</a:t>
-            </a:r>
-          </a:p>
-          <a:p>
-            <a:pPr rtl="0">
-              <a:buFont typeface="Arial" panose="020B0604020202020204" pitchFamily="34" charset="0"/>
-              <a:buChar char="•"/>
-            </a:pPr>
-            <a:r>
+              <a:t>Во-первых, в настоящее время наблюдается устойчивый рост спроса на цифровые образовательные платформы и онлайн-курсы.</a:t>
+            </a:r>
+            <a:br>
               <a:rPr lang="ru-RU" dirty="0"/>
-              <a:t> стремительное развитие и популяризация технологий AR и AI, их интеграция в приложения и веб-платформы;</a:t>
-            </a:r>
-          </a:p>
-          <a:p>
-            <a:pPr rtl="0">
-              <a:buFont typeface="Arial" panose="020B0604020202020204" pitchFamily="34" charset="0"/>
-              <a:buChar char="•"/>
-            </a:pPr>
+            </a:br>
             <a:r>
               <a:rPr lang="ru-RU" dirty="0"/>
-              <a:t> использование AI для обогащения пользовательского опыта посредством интеллектуальных рекомендаций и аналитических комментариев, что поддерживает как начинающих, так и опытных художников;</a:t>
-            </a:r>
-          </a:p>
-          <a:p>
-            <a:pPr rtl="0">
-              <a:buFont typeface="Arial" panose="020B0604020202020204" pitchFamily="34" charset="0"/>
-              <a:buChar char="•"/>
-            </a:pPr>
-            <a:r>
+              <a:t>Во-вторых, пользователи ожидают от подобных систем не только размещения учебных материалов, но и более гибкого функционала: видеоуроков, онлайн-эфиров, чатов, уведомлений и разграничения доступа.</a:t>
+            </a:r>
+            <a:br>
               <a:rPr lang="ru-RU" dirty="0"/>
-              <a:t> применение AR для интерактивного взаимодействия с произведениями искусства, повышающее вовлеченность и интерес аудитории;</a:t>
-            </a:r>
-          </a:p>
-          <a:p>
-            <a:pPr rtl="0">
-              <a:buFont typeface="Arial" panose="020B0604020202020204" pitchFamily="34" charset="0"/>
-              <a:buChar char="•"/>
-            </a:pPr>
+            </a:br>
             <a:r>
               <a:rPr lang="ru-RU" dirty="0"/>
-              <a:t> расширение доступности инструментов для создания современного искусства, что способствует росту числа авторов и популяризации данной сферы.</a:t>
-            </a:r>
-          </a:p>
-          <a:p>
-            <a:pPr marL="0" marR="0" lvl="0" indent="0" algn="l" defTabSz="914400" rtl="0" eaLnBrk="1" fontAlgn="auto" latinLnBrk="0" hangingPunct="1">
-              <a:lnSpc>
-                <a:spcPct val="107000"/>
-              </a:lnSpc>
-              <a:spcBef>
-                <a:spcPts val="0"/>
-              </a:spcBef>
-              <a:spcAft>
-                <a:spcPts val="800"/>
-              </a:spcAft>
-              <a:buClrTx/>
-              <a:buSzTx/>
-              <a:buFontTx/>
-              <a:buNone/>
-              <a:tabLst/>
-              <a:defRPr/>
-            </a:pPr>
-            <a:endParaRPr lang="en-US" sz="1200" dirty="0">
-              <a:effectLst/>
-              <a:latin typeface="Calibri" panose="020F0502020204030204" pitchFamily="34" charset="0"/>
-              <a:ea typeface="Calibri" panose="020F0502020204030204" pitchFamily="34" charset="0"/>
-              <a:cs typeface="Times New Roman" panose="02020603050405020304" pitchFamily="18" charset="0"/>
-            </a:endParaRPr>
-          </a:p>
-          <a:p>
-            <a:endParaRPr lang="en-US" dirty="0"/>
-          </a:p>
-          <a:p>
-            <a:endParaRPr lang="en-US" dirty="0"/>
+              <a:t>В-третьих, важным фактором является необходимость импортозамещения и разработки собственных платформенных решений.</a:t>
+            </a:r>
+            <a:br>
+              <a:rPr lang="ru-RU" dirty="0"/>
+            </a:br>
+            <a:r>
+              <a:rPr lang="ru-RU" dirty="0"/>
+              <a:t>Кроме того, к таким системам предъявляются повышенные требования по безопасности, особенно в части аутентификации, авторизации и защиты доступа к контенту.</a:t>
+            </a:r>
+          </a:p>
+          <a:p>
+            <a:r>
+              <a:rPr lang="ru-RU" dirty="0"/>
+              <a:t>Таким образом, задача разработки надежной и масштабируемой образовательной платформы является актуальной как с практической, так и с инженерной точки зрения.</a:t>
+            </a:r>
           </a:p>
         </p:txBody>
       </p:sp>
@@ -1982,221 +1710,80 @@
           <a:bodyPr/>
           <a:lstStyle/>
           <a:p>
-            <a:pPr marL="0" marR="0" lvl="0" indent="0" algn="l" defTabSz="914400" rtl="0" eaLnBrk="1" fontAlgn="auto" latinLnBrk="0" hangingPunct="1">
-              <a:lnSpc>
-                <a:spcPct val="100000"/>
-              </a:lnSpc>
-              <a:spcBef>
-                <a:spcPts val="0"/>
-              </a:spcBef>
-              <a:spcAft>
-                <a:spcPts val="0"/>
-              </a:spcAft>
-              <a:buClrTx/>
-              <a:buSzTx/>
-              <a:buFontTx/>
-              <a:buNone/>
-              <a:tabLst/>
-              <a:defRPr/>
+            <a:r>
+              <a:rPr lang="ru-RU" dirty="0"/>
+              <a:t>Целью моей работы являлось </a:t>
+            </a:r>
+            <a:r>
+              <a:rPr lang="ru-RU" b="1" dirty="0"/>
+              <a:t>исследование и разработка надежной образовательной платформы с курсами, обеспечивающей управление учебным контентом, пользователями и доступом к ресурсам системы</a:t>
+            </a:r>
+            <a:r>
+              <a:rPr lang="ru-RU" dirty="0"/>
+              <a:t>.</a:t>
+            </a:r>
+          </a:p>
+          <a:p>
+            <a:r>
+              <a:rPr lang="ru-RU" dirty="0"/>
+              <a:t>Для достижения этой цели были поставлены следующие задачи:</a:t>
+            </a:r>
+          </a:p>
+          <a:p>
+            <a:pPr marL="171450" indent="-171450">
+              <a:buFont typeface="Arial" panose="020B0604020202020204" pitchFamily="34" charset="0"/>
+              <a:buChar char="•"/>
             </a:pPr>
             <a:r>
               <a:rPr lang="ru-RU" dirty="0"/>
-              <a:t>Перед реализацией данного проекта была поставлена цель - </a:t>
-            </a:r>
-            <a:r>
-              <a:rPr lang="ru-RU" sz="1200" dirty="0">
-                <a:solidFill>
-                  <a:schemeClr val="tx1">
-                    <a:alpha val="70000"/>
-                  </a:schemeClr>
-                </a:solidFill>
-              </a:rPr>
-              <a:t>разработка веб-приложения, которое сочетает в себе функции дополненной реальности и искусственного интеллекта для художников, работающих в направлении современного искусства.</a:t>
-            </a:r>
-            <a:endParaRPr lang="en-US" sz="1200" dirty="0">
-              <a:solidFill>
-                <a:schemeClr val="tx1">
-                  <a:alpha val="70000"/>
-                </a:schemeClr>
-              </a:solidFill>
-            </a:endParaRPr>
-          </a:p>
-          <a:p>
+              <a:t>провести анализ современных образовательных платформ и их требований; </a:t>
+            </a:r>
+          </a:p>
+          <a:p>
+            <a:pPr marL="171450" indent="-171450">
+              <a:buFont typeface="Arial" panose="020B0604020202020204" pitchFamily="34" charset="0"/>
+              <a:buChar char="•"/>
+            </a:pPr>
             <a:r>
               <a:rPr lang="ru-RU" dirty="0"/>
-              <a:t>Для достижения данной цели были поставлены следующие задачи:</a:t>
-            </a:r>
-          </a:p>
-          <a:p>
-            <a:pPr marL="342900" lvl="0" indent="-342900" algn="just">
-              <a:lnSpc>
-                <a:spcPct val="150000"/>
-              </a:lnSpc>
-              <a:spcBef>
-                <a:spcPts val="600"/>
-              </a:spcBef>
-              <a:spcAft>
-                <a:spcPts val="600"/>
-              </a:spcAft>
-              <a:buFont typeface="+mj-lt"/>
-              <a:buAutoNum type="arabicPeriod"/>
+              <a:t>исследовать подходы к аутентификации, авторизации и управлению доступом; </a:t>
+            </a:r>
+          </a:p>
+          <a:p>
+            <a:pPr marL="171450" indent="-171450">
+              <a:buFont typeface="Arial" panose="020B0604020202020204" pitchFamily="34" charset="0"/>
+              <a:buChar char="•"/>
             </a:pPr>
             <a:r>
-              <a:rPr lang="ru-RU" sz="1800" dirty="0">
-                <a:effectLst/>
-                <a:latin typeface="Times New Roman" panose="02020603050405020304" pitchFamily="18" charset="0"/>
-                <a:ea typeface="Times New Roman" panose="02020603050405020304" pitchFamily="18" charset="0"/>
-              </a:rPr>
-              <a:t>Провести обзор существующих технологий в области AR, AI и их применения в искусстве;</a:t>
-            </a:r>
-            <a:endParaRPr lang="en-US" sz="1800" dirty="0">
-              <a:effectLst/>
-              <a:latin typeface="Times New Roman" panose="02020603050405020304" pitchFamily="18" charset="0"/>
-              <a:ea typeface="Times New Roman" panose="02020603050405020304" pitchFamily="18" charset="0"/>
-            </a:endParaRPr>
-          </a:p>
-          <a:p>
-            <a:pPr marL="342900" lvl="0" indent="-342900" algn="just">
-              <a:lnSpc>
-                <a:spcPct val="150000"/>
-              </a:lnSpc>
-              <a:spcBef>
-                <a:spcPts val="600"/>
-              </a:spcBef>
-              <a:spcAft>
-                <a:spcPts val="600"/>
-              </a:spcAft>
-              <a:buFont typeface="+mj-lt"/>
-              <a:buAutoNum type="arabicPeriod"/>
+              <a:rPr lang="ru-RU" dirty="0"/>
+              <a:t>разработать систему авторизации и разграничения доступа; </a:t>
+            </a:r>
+          </a:p>
+          <a:p>
+            <a:pPr marL="171450" indent="-171450">
+              <a:buFont typeface="Arial" panose="020B0604020202020204" pitchFamily="34" charset="0"/>
+              <a:buChar char="•"/>
             </a:pPr>
             <a:r>
-              <a:rPr lang="ru-RU" sz="1800" dirty="0">
-                <a:effectLst/>
-                <a:latin typeface="Times New Roman" panose="02020603050405020304" pitchFamily="18" charset="0"/>
-                <a:ea typeface="Times New Roman" panose="02020603050405020304" pitchFamily="18" charset="0"/>
-              </a:rPr>
-              <a:t>Разработать пользовательский интерфейс (UI), учитывающий как AR, так и AI-функциональность;</a:t>
-            </a:r>
-            <a:endParaRPr lang="en-US" sz="1800" dirty="0">
-              <a:effectLst/>
-              <a:latin typeface="Times New Roman" panose="02020603050405020304" pitchFamily="18" charset="0"/>
-              <a:ea typeface="Times New Roman" panose="02020603050405020304" pitchFamily="18" charset="0"/>
-            </a:endParaRPr>
-          </a:p>
-          <a:p>
-            <a:pPr marL="342900" lvl="0" indent="-342900" algn="just">
-              <a:lnSpc>
-                <a:spcPct val="150000"/>
-              </a:lnSpc>
-              <a:spcBef>
-                <a:spcPts val="600"/>
-              </a:spcBef>
-              <a:spcAft>
-                <a:spcPts val="600"/>
-              </a:spcAft>
-              <a:buFont typeface="+mj-lt"/>
-              <a:buAutoNum type="arabicPeriod"/>
+              <a:rPr lang="ru-RU" dirty="0"/>
+              <a:t>спроектировать модель системы видео, онлайн-эфиров, уведомлений и чатов; </a:t>
+            </a:r>
+          </a:p>
+          <a:p>
+            <a:pPr marL="171450" indent="-171450">
+              <a:buFont typeface="Arial" panose="020B0604020202020204" pitchFamily="34" charset="0"/>
+              <a:buChar char="•"/>
             </a:pPr>
             <a:r>
-              <a:rPr lang="ru-RU" sz="1800" dirty="0">
-                <a:effectLst/>
-                <a:latin typeface="Times New Roman" panose="02020603050405020304" pitchFamily="18" charset="0"/>
-                <a:ea typeface="Times New Roman" panose="02020603050405020304" pitchFamily="18" charset="0"/>
-              </a:rPr>
-              <a:t>Интегрировать библиотеки и модули для реализации картографической части приложения;</a:t>
-            </a:r>
-            <a:endParaRPr lang="en-US" sz="1800" dirty="0">
-              <a:effectLst/>
-              <a:latin typeface="Times New Roman" panose="02020603050405020304" pitchFamily="18" charset="0"/>
-              <a:ea typeface="Times New Roman" panose="02020603050405020304" pitchFamily="18" charset="0"/>
-            </a:endParaRPr>
-          </a:p>
-          <a:p>
-            <a:pPr marL="342900" lvl="0" indent="-342900" algn="just">
-              <a:lnSpc>
-                <a:spcPct val="150000"/>
-              </a:lnSpc>
-              <a:spcBef>
-                <a:spcPts val="600"/>
-              </a:spcBef>
-              <a:spcAft>
-                <a:spcPts val="600"/>
-              </a:spcAft>
-              <a:buFont typeface="+mj-lt"/>
-              <a:buAutoNum type="arabicPeriod"/>
-            </a:pPr>
-            <a:r>
-              <a:rPr lang="ru-RU" sz="1800" dirty="0">
-                <a:effectLst/>
-                <a:latin typeface="Times New Roman" panose="02020603050405020304" pitchFamily="18" charset="0"/>
-                <a:ea typeface="Times New Roman" panose="02020603050405020304" pitchFamily="18" charset="0"/>
-              </a:rPr>
-              <a:t>Реализовать работу GPT-ассистента, способного отвечать на запросы пользователей, используя заранее заданные профессиональные настройки;</a:t>
-            </a:r>
-            <a:endParaRPr lang="en-US" sz="1800" dirty="0">
-              <a:effectLst/>
-              <a:latin typeface="Times New Roman" panose="02020603050405020304" pitchFamily="18" charset="0"/>
-              <a:ea typeface="Times New Roman" panose="02020603050405020304" pitchFamily="18" charset="0"/>
-            </a:endParaRPr>
-          </a:p>
-          <a:p>
-            <a:pPr marL="342900" lvl="0" indent="-342900" algn="just">
-              <a:lnSpc>
-                <a:spcPct val="150000"/>
-              </a:lnSpc>
-              <a:spcBef>
-                <a:spcPts val="600"/>
-              </a:spcBef>
-              <a:spcAft>
-                <a:spcPts val="600"/>
-              </a:spcAft>
-              <a:buFont typeface="+mj-lt"/>
-              <a:buAutoNum type="arabicPeriod"/>
-            </a:pPr>
-            <a:r>
-              <a:rPr lang="ru-RU" sz="1800" dirty="0">
-                <a:effectLst/>
-                <a:latin typeface="Times New Roman" panose="02020603050405020304" pitchFamily="18" charset="0"/>
-                <a:ea typeface="Times New Roman" panose="02020603050405020304" pitchFamily="18" charset="0"/>
-              </a:rPr>
-              <a:t>Разработать методы взаимодействия пользователя с цифровым контентом в AR и AI-режиме;</a:t>
-            </a:r>
-            <a:endParaRPr lang="en-US" sz="1800" dirty="0">
-              <a:effectLst/>
-              <a:latin typeface="Times New Roman" panose="02020603050405020304" pitchFamily="18" charset="0"/>
-              <a:ea typeface="Times New Roman" panose="02020603050405020304" pitchFamily="18" charset="0"/>
-            </a:endParaRPr>
-          </a:p>
-          <a:p>
-            <a:pPr marL="342900" lvl="0" indent="-342900" algn="just">
-              <a:lnSpc>
-                <a:spcPct val="150000"/>
-              </a:lnSpc>
-              <a:spcBef>
-                <a:spcPts val="600"/>
-              </a:spcBef>
-              <a:spcAft>
-                <a:spcPts val="600"/>
-              </a:spcAft>
-              <a:buFont typeface="+mj-lt"/>
-              <a:buAutoNum type="arabicPeriod"/>
-            </a:pPr>
-            <a:r>
-              <a:rPr lang="ru-RU" sz="1800" dirty="0">
-                <a:effectLst/>
-                <a:latin typeface="Times New Roman" panose="02020603050405020304" pitchFamily="18" charset="0"/>
-                <a:ea typeface="Times New Roman" panose="02020603050405020304" pitchFamily="18" charset="0"/>
-              </a:rPr>
-              <a:t>Провести обзор существующих систем управления подписками и выбрать одну из них для внедрения в приложение.</a:t>
-            </a:r>
-            <a:endParaRPr lang="en-US" sz="1800" dirty="0">
-              <a:effectLst/>
-              <a:latin typeface="Times New Roman" panose="02020603050405020304" pitchFamily="18" charset="0"/>
-              <a:ea typeface="Times New Roman" panose="02020603050405020304" pitchFamily="18" charset="0"/>
-            </a:endParaRPr>
-          </a:p>
-          <a:p>
-            <a:endParaRPr lang="en-US" dirty="0"/>
+              <a:rPr lang="ru-RU" dirty="0"/>
+              <a:t>реализовать данные подсистемы в рамках единой платформы. </a:t>
+            </a:r>
+          </a:p>
+          <a:p>
+            <a:r>
+              <a:rPr lang="ru-RU" dirty="0"/>
+              <a:t>То есть работа включала как исследовательскую часть, так и практическую реализацию ключевых компонентов системы.</a:t>
+            </a:r>
           </a:p>
         </p:txBody>
       </p:sp>
@@ -2280,427 +1867,113 @@
           <a:bodyPr/>
           <a:lstStyle/>
           <a:p>
-            <a:pPr marL="0" marR="0" lvl="0" indent="0" algn="l" defTabSz="914400" rtl="0" eaLnBrk="1" fontAlgn="auto" latinLnBrk="0" hangingPunct="1">
-              <a:lnSpc>
-                <a:spcPct val="100000"/>
-              </a:lnSpc>
-              <a:spcBef>
-                <a:spcPts val="0"/>
-              </a:spcBef>
-              <a:spcAft>
-                <a:spcPts val="0"/>
-              </a:spcAft>
-              <a:buClrTx/>
-              <a:buSzTx/>
-              <a:buFontTx/>
-              <a:buNone/>
-              <a:tabLst/>
-              <a:defRPr/>
-            </a:pPr>
-            <a:r>
-              <a:rPr lang="ru-RU" sz="1800" dirty="0">
-                <a:effectLst/>
-                <a:latin typeface="Times New Roman" panose="02020603050405020304" pitchFamily="18" charset="0"/>
-                <a:ea typeface="Times New Roman" panose="02020603050405020304" pitchFamily="18" charset="0"/>
-              </a:rPr>
-              <a:t>На рис.3 представлена архитектурная схема приложения. Оно делится на две обособленные части: </a:t>
-            </a:r>
-            <a:r>
-              <a:rPr lang="en-US" sz="1800" dirty="0">
-                <a:effectLst/>
-                <a:latin typeface="Times New Roman" panose="02020603050405020304" pitchFamily="18" charset="0"/>
-                <a:ea typeface="Times New Roman" panose="02020603050405020304" pitchFamily="18" charset="0"/>
-              </a:rPr>
-              <a:t>AR</a:t>
-            </a:r>
-            <a:r>
-              <a:rPr lang="ru-RU" sz="1800" dirty="0">
-                <a:effectLst/>
-                <a:latin typeface="Times New Roman" panose="02020603050405020304" pitchFamily="18" charset="0"/>
-                <a:ea typeface="Times New Roman" panose="02020603050405020304" pitchFamily="18" charset="0"/>
-              </a:rPr>
-              <a:t>-часть, отвечающая за дополненную реальность и </a:t>
-            </a:r>
-            <a:r>
-              <a:rPr lang="en-US" sz="1800" dirty="0">
-                <a:effectLst/>
-                <a:latin typeface="Times New Roman" panose="02020603050405020304" pitchFamily="18" charset="0"/>
-                <a:ea typeface="Times New Roman" panose="02020603050405020304" pitchFamily="18" charset="0"/>
-              </a:rPr>
-              <a:t>AI</a:t>
-            </a:r>
-            <a:r>
-              <a:rPr lang="ru-RU" sz="1800" dirty="0">
-                <a:effectLst/>
-                <a:latin typeface="Times New Roman" panose="02020603050405020304" pitchFamily="18" charset="0"/>
-                <a:ea typeface="Times New Roman" panose="02020603050405020304" pitchFamily="18" charset="0"/>
-              </a:rPr>
-              <a:t>-часть, отвечающая за обработку запросов искусственным интеллектом.</a:t>
-            </a:r>
-          </a:p>
-          <a:p>
-            <a:pPr marL="0" marR="0" lvl="0" indent="0" algn="l" defTabSz="914400" rtl="0" eaLnBrk="1" fontAlgn="auto" latinLnBrk="0" hangingPunct="1">
-              <a:lnSpc>
-                <a:spcPct val="100000"/>
-              </a:lnSpc>
-              <a:spcBef>
-                <a:spcPts val="0"/>
-              </a:spcBef>
-              <a:spcAft>
-                <a:spcPts val="0"/>
-              </a:spcAft>
-              <a:buClrTx/>
-              <a:buSzTx/>
-              <a:buFontTx/>
-              <a:buNone/>
-              <a:tabLst/>
-              <a:defRPr/>
-            </a:pPr>
-            <a:endParaRPr lang="ru-RU" sz="1800" dirty="0">
-              <a:effectLst/>
-              <a:latin typeface="Times New Roman" panose="02020603050405020304" pitchFamily="18" charset="0"/>
-              <a:ea typeface="Times New Roman" panose="02020603050405020304" pitchFamily="18" charset="0"/>
-            </a:endParaRPr>
-          </a:p>
-          <a:p>
-            <a:pPr marL="0" marR="0" lvl="0" indent="0" algn="l" defTabSz="914400" rtl="0" eaLnBrk="1" fontAlgn="auto" latinLnBrk="0" hangingPunct="1">
-              <a:lnSpc>
-                <a:spcPct val="100000"/>
-              </a:lnSpc>
-              <a:spcBef>
-                <a:spcPts val="0"/>
-              </a:spcBef>
-              <a:spcAft>
-                <a:spcPts val="0"/>
-              </a:spcAft>
-              <a:buClrTx/>
-              <a:buSzTx/>
-              <a:buFontTx/>
-              <a:buNone/>
-              <a:tabLst/>
-              <a:defRPr/>
-            </a:pPr>
-            <a:r>
-              <a:rPr lang="ru-RU" sz="1800" dirty="0">
-                <a:effectLst/>
-                <a:latin typeface="Times New Roman" panose="02020603050405020304" pitchFamily="18" charset="0"/>
-                <a:ea typeface="Times New Roman" panose="02020603050405020304" pitchFamily="18" charset="0"/>
-              </a:rPr>
-              <a:t>AR-компонент разрабатывался с использованием платформы 8th Wall и фреймворка A-Frame. Он отвечает за визуализацию галереи и </a:t>
-            </a:r>
-            <a:r>
-              <a:rPr lang="ru-RU" sz="1800" dirty="0" err="1">
-                <a:effectLst/>
-                <a:latin typeface="Times New Roman" panose="02020603050405020304" pitchFamily="18" charset="0"/>
-                <a:ea typeface="Times New Roman" panose="02020603050405020304" pitchFamily="18" charset="0"/>
-              </a:rPr>
-              <a:t>геопривязку</a:t>
-            </a:r>
-            <a:r>
-              <a:rPr lang="ru-RU" sz="1800" dirty="0">
-                <a:effectLst/>
-                <a:latin typeface="Times New Roman" panose="02020603050405020304" pitchFamily="18" charset="0"/>
-                <a:ea typeface="Times New Roman" panose="02020603050405020304" pitchFamily="18" charset="0"/>
-              </a:rPr>
-              <a:t> произведений искусства. Хостинг данного модуля осуществляется через инфраструктуру 8th Wall, что упрощает интеграцию с камерами мобильных устройств и расширяет кроссплатформенность. </a:t>
-            </a:r>
-          </a:p>
-          <a:p>
-            <a:pPr marL="0" marR="0" lvl="0" indent="0" algn="l" defTabSz="914400" rtl="0" eaLnBrk="1" fontAlgn="auto" latinLnBrk="0" hangingPunct="1">
-              <a:lnSpc>
-                <a:spcPct val="100000"/>
-              </a:lnSpc>
-              <a:spcBef>
-                <a:spcPts val="0"/>
-              </a:spcBef>
-              <a:spcAft>
-                <a:spcPts val="0"/>
-              </a:spcAft>
-              <a:buClrTx/>
-              <a:buSzTx/>
-              <a:buFontTx/>
-              <a:buNone/>
-              <a:tabLst/>
-              <a:defRPr/>
-            </a:pPr>
-            <a:endParaRPr lang="ru-RU" sz="1800" dirty="0">
-              <a:effectLst/>
-              <a:latin typeface="Times New Roman" panose="02020603050405020304" pitchFamily="18" charset="0"/>
-              <a:ea typeface="Times New Roman" panose="02020603050405020304" pitchFamily="18" charset="0"/>
-            </a:endParaRPr>
-          </a:p>
-          <a:p>
-            <a:pPr marL="0" marR="0" lvl="0" indent="0" algn="l" defTabSz="914400" rtl="0" eaLnBrk="1" fontAlgn="auto" latinLnBrk="0" hangingPunct="1">
-              <a:lnSpc>
-                <a:spcPct val="100000"/>
-              </a:lnSpc>
-              <a:spcBef>
-                <a:spcPts val="0"/>
-              </a:spcBef>
-              <a:spcAft>
-                <a:spcPts val="0"/>
-              </a:spcAft>
-              <a:buClrTx/>
-              <a:buSzTx/>
-              <a:buFontTx/>
-              <a:buNone/>
-              <a:tabLst/>
-              <a:defRPr/>
-            </a:pPr>
-            <a:r>
-              <a:rPr lang="ru-RU" sz="1800" dirty="0">
-                <a:effectLst/>
-                <a:latin typeface="Times New Roman" panose="02020603050405020304" pitchFamily="18" charset="0"/>
-                <a:ea typeface="Times New Roman" panose="02020603050405020304" pitchFamily="18" charset="0"/>
-              </a:rPr>
-              <a:t>AI-компонент построен на стеке Next.js, </a:t>
-            </a:r>
-            <a:r>
-              <a:rPr lang="ru-RU" sz="1800" dirty="0" err="1">
-                <a:effectLst/>
-                <a:latin typeface="Times New Roman" panose="02020603050405020304" pitchFamily="18" charset="0"/>
-                <a:ea typeface="Times New Roman" panose="02020603050405020304" pitchFamily="18" charset="0"/>
-              </a:rPr>
-              <a:t>TypeScript</a:t>
-            </a:r>
-            <a:r>
-              <a:rPr lang="ru-RU" sz="1800" dirty="0">
-                <a:effectLst/>
-                <a:latin typeface="Times New Roman" panose="02020603050405020304" pitchFamily="18" charset="0"/>
-                <a:ea typeface="Times New Roman" panose="02020603050405020304" pitchFamily="18" charset="0"/>
-              </a:rPr>
-              <a:t> и </a:t>
-            </a:r>
-            <a:r>
-              <a:rPr lang="ru-RU" sz="1800" dirty="0" err="1">
-                <a:effectLst/>
-                <a:latin typeface="Times New Roman" panose="02020603050405020304" pitchFamily="18" charset="0"/>
-                <a:ea typeface="Times New Roman" panose="02020603050405020304" pitchFamily="18" charset="0"/>
-              </a:rPr>
-              <a:t>React</a:t>
-            </a:r>
-            <a:r>
-              <a:rPr lang="ru-RU" sz="1800" dirty="0">
-                <a:effectLst/>
-                <a:latin typeface="Times New Roman" panose="02020603050405020304" pitchFamily="18" charset="0"/>
-                <a:ea typeface="Times New Roman" panose="02020603050405020304" pitchFamily="18" charset="0"/>
-              </a:rPr>
-              <a:t> и размещён на платформе </a:t>
-            </a:r>
-            <a:r>
-              <a:rPr lang="ru-RU" sz="1800" dirty="0" err="1">
-                <a:effectLst/>
-                <a:latin typeface="Times New Roman" panose="02020603050405020304" pitchFamily="18" charset="0"/>
-                <a:ea typeface="Times New Roman" panose="02020603050405020304" pitchFamily="18" charset="0"/>
-              </a:rPr>
-              <a:t>Vercel</a:t>
-            </a:r>
-            <a:r>
-              <a:rPr lang="ru-RU" sz="1800" dirty="0">
-                <a:effectLst/>
-                <a:latin typeface="Times New Roman" panose="02020603050405020304" pitchFamily="18" charset="0"/>
-                <a:ea typeface="Times New Roman" panose="02020603050405020304" pitchFamily="18" charset="0"/>
-              </a:rPr>
-              <a:t>. Он обеспечивает доступ к функциональности GPT-ассистента, управление подписками, авторизацию пользователей, хранение и обработку данных. Между двумя компонентами отсутствует прямая техническая интеграция, однако реализован переход по ссылке, обеспечивающий логическую связность и плавную навигацию между AR- и AI-модулями.</a:t>
-            </a:r>
-            <a:endParaRPr lang="en-US" sz="1800" dirty="0">
-              <a:effectLst/>
-              <a:latin typeface="Times New Roman" panose="02020603050405020304" pitchFamily="18" charset="0"/>
-              <a:ea typeface="Times New Roman" panose="02020603050405020304" pitchFamily="18" charset="0"/>
-            </a:endParaRPr>
-          </a:p>
-          <a:p>
-            <a:endParaRPr lang="ru-RU" dirty="0"/>
-          </a:p>
-          <a:p>
-            <a:pPr marL="0" lvl="0" indent="0" algn="l">
-              <a:lnSpc>
-                <a:spcPct val="150000"/>
-              </a:lnSpc>
-              <a:spcBef>
-                <a:spcPts val="600"/>
-              </a:spcBef>
-              <a:spcAft>
-                <a:spcPts val="600"/>
-              </a:spcAft>
-              <a:buFont typeface="Symbol" panose="05050102010706020507" pitchFamily="18" charset="2"/>
-              <a:buNone/>
-            </a:pPr>
-            <a:r>
-              <a:rPr lang="ru-RU" dirty="0"/>
-              <a:t>В </a:t>
-            </a:r>
-            <a:r>
-              <a:rPr lang="en-US" dirty="0"/>
-              <a:t>AI-</a:t>
-            </a:r>
-            <a:r>
-              <a:rPr lang="ru-RU" dirty="0"/>
-              <a:t>компоненте в бэкенде происходят обращения к следующим системам:</a:t>
-            </a:r>
-          </a:p>
-          <a:p>
-            <a:pPr marL="285750" lvl="0" indent="-285750" algn="l">
-              <a:lnSpc>
-                <a:spcPct val="150000"/>
-              </a:lnSpc>
-              <a:spcBef>
-                <a:spcPts val="600"/>
-              </a:spcBef>
-              <a:spcAft>
-                <a:spcPts val="600"/>
-              </a:spcAft>
-              <a:buFont typeface="Arial" panose="020B0604020202020204" pitchFamily="34" charset="0"/>
-              <a:buChar char="•"/>
-            </a:pPr>
-            <a:r>
-              <a:rPr lang="ru-RU" sz="1800" dirty="0" err="1">
-                <a:effectLst/>
-                <a:latin typeface="Times New Roman" panose="02020603050405020304" pitchFamily="18" charset="0"/>
-                <a:ea typeface="Times New Roman" panose="02020603050405020304" pitchFamily="18" charset="0"/>
-              </a:rPr>
-              <a:t>OpenAI</a:t>
-            </a:r>
-            <a:r>
-              <a:rPr lang="ru-RU" sz="1800" dirty="0">
-                <a:effectLst/>
-                <a:latin typeface="Times New Roman" panose="02020603050405020304" pitchFamily="18" charset="0"/>
-                <a:ea typeface="Times New Roman" panose="02020603050405020304" pitchFamily="18" charset="0"/>
-              </a:rPr>
-              <a:t> API — генерация ответов с использованием модели GPT-4o-mini;</a:t>
-            </a:r>
-            <a:endParaRPr lang="en-US" sz="1800" dirty="0">
-              <a:effectLst/>
-              <a:latin typeface="Times New Roman" panose="02020603050405020304" pitchFamily="18" charset="0"/>
-              <a:ea typeface="Times New Roman" panose="02020603050405020304" pitchFamily="18" charset="0"/>
-            </a:endParaRPr>
-          </a:p>
-          <a:p>
-            <a:pPr marL="342900" lvl="0" indent="-342900" algn="just">
-              <a:lnSpc>
-                <a:spcPct val="150000"/>
-              </a:lnSpc>
-              <a:spcBef>
-                <a:spcPts val="600"/>
-              </a:spcBef>
-              <a:spcAft>
-                <a:spcPts val="600"/>
-              </a:spcAft>
-              <a:buFont typeface="Symbol" panose="05050102010706020507" pitchFamily="18" charset="2"/>
-              <a:buChar char=""/>
-            </a:pPr>
-            <a:r>
-              <a:rPr lang="ru-RU" sz="1800" dirty="0" err="1">
-                <a:effectLst/>
-                <a:latin typeface="Times New Roman" panose="02020603050405020304" pitchFamily="18" charset="0"/>
-                <a:ea typeface="Times New Roman" panose="02020603050405020304" pitchFamily="18" charset="0"/>
-              </a:rPr>
-              <a:t>Supabase</a:t>
-            </a:r>
-            <a:r>
-              <a:rPr lang="ru-RU" sz="1800" dirty="0">
-                <a:effectLst/>
-                <a:latin typeface="Times New Roman" panose="02020603050405020304" pitchFamily="18" charset="0"/>
-                <a:ea typeface="Times New Roman" panose="02020603050405020304" pitchFamily="18" charset="0"/>
-              </a:rPr>
-              <a:t> — хранилище данных, а также источник информации о пользователях, тарифах и лимитах;</a:t>
-            </a:r>
-            <a:endParaRPr lang="en-US" sz="1800" dirty="0">
-              <a:effectLst/>
-              <a:latin typeface="Times New Roman" panose="02020603050405020304" pitchFamily="18" charset="0"/>
-              <a:ea typeface="Times New Roman" panose="02020603050405020304" pitchFamily="18" charset="0"/>
-            </a:endParaRPr>
-          </a:p>
-          <a:p>
-            <a:pPr marL="342900" lvl="0" indent="-342900" algn="just">
-              <a:lnSpc>
-                <a:spcPct val="150000"/>
-              </a:lnSpc>
-              <a:spcBef>
-                <a:spcPts val="600"/>
-              </a:spcBef>
-              <a:spcAft>
-                <a:spcPts val="600"/>
-              </a:spcAft>
-              <a:buFont typeface="Symbol" panose="05050102010706020507" pitchFamily="18" charset="2"/>
-              <a:buChar char=""/>
-            </a:pPr>
-            <a:r>
-              <a:rPr lang="ru-RU" sz="1800" dirty="0" err="1">
-                <a:effectLst/>
-                <a:latin typeface="Times New Roman" panose="02020603050405020304" pitchFamily="18" charset="0"/>
-                <a:ea typeface="Times New Roman" panose="02020603050405020304" pitchFamily="18" charset="0"/>
-              </a:rPr>
-              <a:t>Twitter</a:t>
-            </a:r>
-            <a:r>
-              <a:rPr lang="ru-RU" sz="1800" dirty="0">
-                <a:effectLst/>
-                <a:latin typeface="Times New Roman" panose="02020603050405020304" pitchFamily="18" charset="0"/>
-                <a:ea typeface="Times New Roman" panose="02020603050405020304" pitchFamily="18" charset="0"/>
-              </a:rPr>
-              <a:t> API — используется для авторизации пользователей;</a:t>
-            </a:r>
-            <a:endParaRPr lang="en-US" sz="1800" dirty="0">
-              <a:effectLst/>
-              <a:latin typeface="Times New Roman" panose="02020603050405020304" pitchFamily="18" charset="0"/>
-              <a:ea typeface="Times New Roman" panose="02020603050405020304" pitchFamily="18" charset="0"/>
-            </a:endParaRPr>
-          </a:p>
-          <a:p>
-            <a:pPr marL="342900" lvl="0" indent="-342900" algn="just">
-              <a:lnSpc>
-                <a:spcPct val="150000"/>
-              </a:lnSpc>
-              <a:spcBef>
-                <a:spcPts val="600"/>
-              </a:spcBef>
-              <a:spcAft>
-                <a:spcPts val="600"/>
-              </a:spcAft>
-              <a:buFont typeface="Symbol" panose="05050102010706020507" pitchFamily="18" charset="2"/>
-              <a:buChar char=""/>
-            </a:pPr>
-            <a:r>
-              <a:rPr lang="ru-RU" sz="1800" dirty="0" err="1">
-                <a:effectLst/>
-                <a:latin typeface="Times New Roman" panose="02020603050405020304" pitchFamily="18" charset="0"/>
-                <a:ea typeface="Times New Roman" panose="02020603050405020304" pitchFamily="18" charset="0"/>
-              </a:rPr>
-              <a:t>Stripe</a:t>
-            </a:r>
-            <a:r>
-              <a:rPr lang="ru-RU" sz="1800" dirty="0">
-                <a:effectLst/>
-                <a:latin typeface="Times New Roman" panose="02020603050405020304" pitchFamily="18" charset="0"/>
-                <a:ea typeface="Times New Roman" panose="02020603050405020304" pitchFamily="18" charset="0"/>
-              </a:rPr>
-              <a:t> — платёжная система, интегрированная с </a:t>
-            </a:r>
-            <a:r>
-              <a:rPr lang="ru-RU" sz="1800" dirty="0" err="1">
-                <a:effectLst/>
-                <a:latin typeface="Times New Roman" panose="02020603050405020304" pitchFamily="18" charset="0"/>
-                <a:ea typeface="Times New Roman" panose="02020603050405020304" pitchFamily="18" charset="0"/>
-              </a:rPr>
-              <a:t>Supabase</a:t>
-            </a:r>
-            <a:r>
-              <a:rPr lang="ru-RU" sz="1800" dirty="0">
-                <a:effectLst/>
-                <a:latin typeface="Times New Roman" panose="02020603050405020304" pitchFamily="18" charset="0"/>
-                <a:ea typeface="Times New Roman" panose="02020603050405020304" pitchFamily="18" charset="0"/>
-              </a:rPr>
-              <a:t> и обеспечивающая тарификацию.</a:t>
-            </a:r>
-            <a:endParaRPr lang="en-US" sz="1800" dirty="0">
-              <a:effectLst/>
-              <a:latin typeface="Times New Roman" panose="02020603050405020304" pitchFamily="18" charset="0"/>
-              <a:ea typeface="Times New Roman" panose="02020603050405020304" pitchFamily="18" charset="0"/>
-            </a:endParaRPr>
-          </a:p>
-          <a:p>
-            <a:endParaRPr lang="en-US" dirty="0"/>
+            <a:r>
+              <a:rPr lang="ru-RU" sz="1800" dirty="0"/>
+              <a:t>На данном слайде представлена общая архитектура разработанной платформы.</a:t>
+            </a:r>
+          </a:p>
+          <a:p>
+            <a:r>
+              <a:rPr lang="ru-RU" sz="1800" dirty="0"/>
+              <a:t>Система построена как набор взаимодействующих компонентов, каждый из которых отвечает за свою зону ответственности.</a:t>
+            </a:r>
+            <a:br>
+              <a:rPr lang="ru-RU" sz="1800" dirty="0"/>
+            </a:br>
+            <a:r>
+              <a:rPr lang="ru-RU" sz="1800" dirty="0"/>
+              <a:t>В качестве серверной основы использован </a:t>
+            </a:r>
+            <a:r>
+              <a:rPr lang="ru-RU" sz="1800" dirty="0" err="1"/>
+              <a:t>backend</a:t>
+            </a:r>
+            <a:r>
+              <a:rPr lang="ru-RU" sz="1800" dirty="0"/>
+              <a:t> на </a:t>
+            </a:r>
+            <a:r>
+              <a:rPr lang="ru-RU" sz="1800" b="1" dirty="0" err="1"/>
+              <a:t>Golang</a:t>
+            </a:r>
+            <a:r>
+              <a:rPr lang="ru-RU" sz="1800" dirty="0"/>
+              <a:t>.</a:t>
+            </a:r>
+            <a:br>
+              <a:rPr lang="ru-RU" sz="1800" dirty="0"/>
+            </a:br>
+            <a:r>
+              <a:rPr lang="ru-RU" sz="1800" dirty="0"/>
+              <a:t>Для хранения основной структурированной информации применяется </a:t>
+            </a:r>
+            <a:r>
+              <a:rPr lang="ru-RU" sz="1800" b="1" dirty="0" err="1"/>
+              <a:t>PostgreSQL</a:t>
+            </a:r>
+            <a:r>
+              <a:rPr lang="ru-RU" sz="1800" dirty="0"/>
+              <a:t>, для кэширования и временных данных — </a:t>
+            </a:r>
+            <a:r>
+              <a:rPr lang="ru-RU" sz="1800" b="1" dirty="0" err="1"/>
+              <a:t>Redis</a:t>
+            </a:r>
+            <a:r>
+              <a:rPr lang="ru-RU" sz="1800" dirty="0"/>
+              <a:t>.</a:t>
+            </a:r>
+            <a:br>
+              <a:rPr lang="ru-RU" sz="1800" dirty="0"/>
+            </a:br>
+            <a:r>
+              <a:rPr lang="ru-RU" sz="1800" dirty="0"/>
+              <a:t>Для событийного взаимодействия между компонентами системы используется </a:t>
+            </a:r>
+            <a:r>
+              <a:rPr lang="ru-RU" sz="1800" b="1" dirty="0" err="1"/>
+              <a:t>Kafka</a:t>
+            </a:r>
+            <a:r>
+              <a:rPr lang="ru-RU" sz="1800" dirty="0"/>
+              <a:t>.</a:t>
+            </a:r>
+            <a:br>
+              <a:rPr lang="ru-RU" sz="1800" dirty="0"/>
+            </a:br>
+            <a:r>
+              <a:rPr lang="ru-RU" sz="1800" dirty="0"/>
+              <a:t>Для чатов и уведомлений в реальном времени применяется </a:t>
+            </a:r>
+            <a:r>
+              <a:rPr lang="ru-RU" sz="1800" b="1" dirty="0" err="1"/>
+              <a:t>Centrifugo</a:t>
+            </a:r>
+            <a:r>
+              <a:rPr lang="ru-RU" sz="1800" dirty="0"/>
+              <a:t>.</a:t>
+            </a:r>
+            <a:br>
+              <a:rPr lang="ru-RU" sz="1800" dirty="0"/>
+            </a:br>
+            <a:r>
+              <a:rPr lang="ru-RU" sz="1800" dirty="0"/>
+              <a:t>Видео и дополнительные материалы хранятся в </a:t>
+            </a:r>
+            <a:r>
+              <a:rPr lang="ru-RU" sz="1800" b="1" dirty="0"/>
+              <a:t>S3-совместимом хранилище</a:t>
+            </a:r>
+            <a:r>
+              <a:rPr lang="ru-RU" sz="1800" dirty="0"/>
+              <a:t>, а воспроизведение видео и проведение эфиров реализованы через уже готовый собственный видеосервис.</a:t>
+            </a:r>
+          </a:p>
+          <a:p>
+            <a:r>
+              <a:rPr lang="ru-RU" sz="1800" dirty="0"/>
+              <a:t>Такой подход позволяет сделать систему расширяемой, обеспечить разделение ответственности между компонентами и подготовить платформу к дальнейшему масштабированию.</a:t>
+            </a:r>
           </a:p>
         </p:txBody>
       </p:sp>
@@ -2784,78 +2057,117 @@
           <a:bodyPr/>
           <a:lstStyle/>
           <a:p>
-            <a:pPr rtl="0"/>
             <a:r>
               <a:rPr lang="ru-RU" dirty="0"/>
-              <a:t>Протокол </a:t>
-            </a:r>
+              <a:t>На этом слайде показан механизм авторизации пользователей.</a:t>
+            </a:r>
+          </a:p>
+          <a:p>
+            <a:r>
+              <a:rPr lang="ru-RU" dirty="0"/>
+              <a:t>В основе выбранного подхода лежат </a:t>
+            </a:r>
+            <a:r>
+              <a:rPr lang="ru-RU" b="1" dirty="0" err="1"/>
+              <a:t>OAuth</a:t>
+            </a:r>
+            <a:r>
+              <a:rPr lang="ru-RU" b="1" dirty="0"/>
+              <a:t> 2.0</a:t>
+            </a:r>
+            <a:r>
+              <a:rPr lang="ru-RU" dirty="0"/>
+              <a:t> и </a:t>
+            </a:r>
+            <a:r>
+              <a:rPr lang="ru-RU" b="1" dirty="0" err="1"/>
+              <a:t>OpenID</a:t>
+            </a:r>
+            <a:r>
+              <a:rPr lang="ru-RU" b="1" dirty="0"/>
+              <a:t> Connect</a:t>
+            </a:r>
+            <a:r>
+              <a:rPr lang="ru-RU" dirty="0"/>
+              <a:t>.</a:t>
+            </a:r>
+            <a:br>
+              <a:rPr lang="ru-RU" dirty="0"/>
+            </a:br>
             <a:r>
               <a:rPr lang="ru-RU" dirty="0" err="1"/>
               <a:t>OAuth</a:t>
             </a:r>
             <a:r>
               <a:rPr lang="ru-RU" dirty="0"/>
-              <a:t> 2.0 предлагает стандартизированный механизм авторизации, обеспечивающий интеграцию с внешними сервисами. Он позволяет пользователям предоставлять приложению доступ к определённым данным или функциям своего аккаунта (логины, пароли) без их прямой передачи.</a:t>
-            </a:r>
-          </a:p>
-          <a:p>
-            <a:pPr rtl="0"/>
+              <a:t> 2.0 используется как протокол авторизации, а OIDC дополняет его механизмом подтверждения личности пользователя. (аутентификации)</a:t>
+            </a:r>
+          </a:p>
+          <a:p>
             <a:r>
               <a:rPr lang="ru-RU" dirty="0"/>
-              <a:t>На схеме представлен процесс: пользователь запрашивает доступ через </a:t>
+              <a:t>Для повышения безопасности применяется </a:t>
+            </a:r>
+            <a:r>
+              <a:rPr lang="ru-RU" b="1" dirty="0"/>
+              <a:t>PKCE</a:t>
+            </a:r>
+            <a:r>
+              <a:rPr lang="ru-RU" dirty="0"/>
+              <a:t>.</a:t>
+            </a:r>
+            <a:br>
+              <a:rPr lang="ru-RU" dirty="0"/>
+            </a:br>
+            <a:r>
+              <a:rPr lang="ru-RU" dirty="0"/>
+              <a:t>Его основная задача состоит в том, чтобы защитить процесс обмена </a:t>
             </a:r>
             <a:r>
               <a:rPr lang="ru-RU" dirty="0" err="1"/>
-              <a:t>Twitter</a:t>
+              <a:t>authorization</a:t>
             </a:r>
             <a:r>
               <a:rPr lang="ru-RU" dirty="0"/>
-              <a:t>-сервер, получает токен доступа, а приложение использует его для обращения к API </a:t>
+              <a:t> </a:t>
             </a:r>
             <a:r>
               <a:rPr lang="ru-RU" dirty="0" err="1"/>
-              <a:t>Twitter</a:t>
+              <a:t>code</a:t>
             </a:r>
             <a:r>
               <a:rPr lang="ru-RU" dirty="0"/>
-              <a:t>. Если токен отсутствует или недействителен, запрос либо отклоняется и пользователь возвращается на нашу страницу авторизации.</a:t>
-            </a:r>
-          </a:p>
-          <a:p>
-            <a:pPr rtl="0"/>
-            <a:endParaRPr lang="ru-RU" dirty="0"/>
-          </a:p>
-          <a:p>
-            <a:pPr marL="0" marR="0" lvl="0" indent="0" algn="l" defTabSz="914400" rtl="0" eaLnBrk="1" fontAlgn="auto" latinLnBrk="0" hangingPunct="1">
-              <a:lnSpc>
-                <a:spcPct val="100000"/>
-              </a:lnSpc>
-              <a:spcBef>
-                <a:spcPts val="0"/>
-              </a:spcBef>
-              <a:spcAft>
-                <a:spcPts val="0"/>
-              </a:spcAft>
-              <a:buClrTx/>
-              <a:buSzTx/>
-              <a:buFontTx/>
-              <a:buNone/>
-              <a:tabLst/>
-              <a:defRPr/>
-            </a:pPr>
-            <a:r>
-              <a:rPr lang="en-US" sz="1200" dirty="0">
-                <a:effectLst/>
-                <a:latin typeface="Times New Roman" panose="02020603050405020304" pitchFamily="18" charset="0"/>
-                <a:ea typeface="Calibri" panose="020F0502020204030204" pitchFamily="34" charset="0"/>
-              </a:rPr>
-              <a:t>PKCE – proof key for code exchange</a:t>
-            </a:r>
-            <a:endParaRPr lang="ru-RU" sz="1200" dirty="0">
-              <a:effectLst/>
-              <a:latin typeface="Times New Roman" panose="02020603050405020304" pitchFamily="18" charset="0"/>
-              <a:ea typeface="Calibri" panose="020F0502020204030204" pitchFamily="34" charset="0"/>
-            </a:endParaRPr>
+              <a:t> на токен и исключить возможность использования перехваченного кода злоумышленником.</a:t>
+            </a:r>
+          </a:p>
+          <a:p>
+            <a:r>
+              <a:rPr lang="ru-RU" dirty="0"/>
+              <a:t>После успешной аутентификации пользователь получает токен доступа, который далее используется для обращения к </a:t>
+            </a:r>
+            <a:r>
+              <a:rPr lang="ru-RU" dirty="0" err="1"/>
+              <a:t>backend</a:t>
+            </a:r>
+            <a:r>
+              <a:rPr lang="ru-RU" dirty="0"/>
+              <a:t> API.</a:t>
+            </a:r>
+            <a:br>
+              <a:rPr lang="ru-RU" dirty="0"/>
+            </a:br>
+            <a:r>
+              <a:rPr lang="ru-RU" dirty="0"/>
+              <a:t>При этом </a:t>
+            </a:r>
+            <a:r>
+              <a:rPr lang="ru-RU" dirty="0" err="1"/>
+              <a:t>backend</a:t>
+            </a:r>
+            <a:r>
+              <a:rPr lang="ru-RU" dirty="0"/>
+              <a:t> не только валидирует токен, но и проверяет права пользователя на конкретные ресурсы системы.</a:t>
+            </a:r>
           </a:p>
           <a:p>
             <a:endParaRPr lang="en-US" dirty="0"/>
@@ -2942,6 +2254,82 @@
           <a:bodyPr/>
           <a:lstStyle/>
           <a:p>
+            <a:r>
+              <a:rPr lang="ru-RU" dirty="0"/>
+              <a:t>На данном слайде показана практическая реализация авторизации в разработанной платформе.</a:t>
+            </a:r>
+          </a:p>
+          <a:p>
+            <a:r>
+              <a:rPr lang="ru-RU" dirty="0"/>
+              <a:t>Для реализации системы авторизации был выбран </a:t>
+            </a:r>
+            <a:r>
+              <a:rPr lang="ru-RU" dirty="0" err="1"/>
+              <a:t>опенсурсный</a:t>
+            </a:r>
+            <a:r>
+              <a:rPr lang="ru-RU" dirty="0"/>
+              <a:t> </a:t>
+            </a:r>
+            <a:r>
+              <a:rPr lang="ru-RU" b="1" dirty="0"/>
+              <a:t>ORY </a:t>
+            </a:r>
+            <a:r>
+              <a:rPr lang="ru-RU" b="1" dirty="0" err="1"/>
+              <a:t>Hydra</a:t>
+            </a:r>
+            <a:r>
+              <a:rPr lang="ru-RU" dirty="0"/>
+              <a:t>, который выступает в роли </a:t>
+            </a:r>
+            <a:r>
+              <a:rPr lang="ru-RU" dirty="0" err="1"/>
+              <a:t>authorization</a:t>
+            </a:r>
+            <a:r>
+              <a:rPr lang="ru-RU" dirty="0"/>
+              <a:t> </a:t>
+            </a:r>
+            <a:r>
+              <a:rPr lang="ru-RU" dirty="0" err="1"/>
+              <a:t>server</a:t>
+            </a:r>
+            <a:r>
+              <a:rPr lang="ru-RU" dirty="0"/>
+              <a:t> и отвечает за выдачу токенов, поддержку </a:t>
+            </a:r>
+            <a:r>
+              <a:rPr lang="ru-RU" dirty="0" err="1"/>
+              <a:t>OAuth</a:t>
+            </a:r>
+            <a:r>
+              <a:rPr lang="ru-RU" dirty="0"/>
+              <a:t> 2.0, OIDC и PKCE.</a:t>
+            </a:r>
+          </a:p>
+          <a:p>
+            <a:r>
+              <a:rPr lang="ru-RU" dirty="0"/>
+              <a:t>Такой подход позволяет не реализовывать критически важную </a:t>
+            </a:r>
+            <a:r>
+              <a:rPr lang="ru-RU" dirty="0" err="1"/>
+              <a:t>auth</a:t>
+            </a:r>
+            <a:r>
+              <a:rPr lang="ru-RU" dirty="0"/>
+              <a:t>-логику полностью вручную, а использовать специализированное решение, соответствующее современным стандартам безопасности.</a:t>
+            </a:r>
+          </a:p>
+          <a:p>
+            <a:r>
+              <a:rPr lang="ru-RU" dirty="0"/>
+              <a:t>В результате система поддерживает безопасный процесс входа пользователя, выдачу JWT-токенов и дальнейшее использование этих токенов при обращении к защищённым ресурсам платформы.</a:t>
+            </a:r>
+          </a:p>
+          <a:p>
             <a:endParaRPr lang="en-US" dirty="0"/>
           </a:p>
         </p:txBody>
@@ -3026,32 +2414,104 @@
           <a:bodyPr/>
           <a:lstStyle/>
           <a:p>
-            <a:pPr rtl="0"/>
             <a:r>
               <a:rPr lang="ru-RU" sz="4000" dirty="0"/>
-              <a:t>Рассказать про </a:t>
+              <a:t>На этом слайде представлена ролевая модель доступа, используемая в системе.</a:t>
+            </a:r>
+          </a:p>
+          <a:p>
+            <a:r>
+              <a:rPr lang="ru-RU" sz="4000" dirty="0"/>
+              <a:t>Для управления доступом был выбран подход </a:t>
+            </a:r>
+            <a:r>
+              <a:rPr lang="ru-RU" sz="4000" b="1" dirty="0" err="1"/>
+              <a:t>ReBAC</a:t>
+            </a:r>
+            <a:r>
+              <a:rPr lang="ru-RU" sz="4000" dirty="0"/>
+              <a:t>, реализованный с помощью </a:t>
+            </a:r>
+            <a:r>
+              <a:rPr lang="ru-RU" sz="4000" b="1" dirty="0"/>
+              <a:t>ORY </a:t>
+            </a:r>
+            <a:r>
+              <a:rPr lang="ru-RU" sz="4000" b="1" dirty="0" err="1"/>
+              <a:t>Keto</a:t>
+            </a:r>
+            <a:r>
+              <a:rPr lang="ru-RU" sz="4000" dirty="0"/>
+              <a:t>.</a:t>
+            </a:r>
+            <a:br>
+              <a:rPr lang="ru-RU" sz="4000" dirty="0"/>
+            </a:br>
+            <a:r>
+              <a:rPr lang="ru-RU" sz="4000" dirty="0"/>
+              <a:t>В отличие от классической RBAC-модели, где доступ строится только на основе ролей, </a:t>
             </a:r>
             <a:r>
               <a:rPr lang="ru-RU" sz="4000" dirty="0" err="1"/>
-              <a:t>неймспейс:объект</a:t>
-            </a:r>
-            <a:r>
-              <a:rPr lang="en-US" sz="4000" dirty="0"/>
-              <a:t>#</a:t>
+              <a:t>ReBAC</a:t>
             </a:r>
             <a:r>
               <a:rPr lang="ru-RU" sz="4000" dirty="0"/>
-              <a:t>отношение</a:t>
-            </a:r>
-            <a:r>
-              <a:rPr lang="en-US" sz="4000" dirty="0"/>
-              <a:t>@</a:t>
-            </a:r>
-            <a:r>
-              <a:rPr lang="ru-RU" sz="4000" dirty="0" err="1"/>
-              <a:t>неймспейс:объект</a:t>
-            </a:r>
-            <a:endParaRPr lang="ru-RU" sz="4000" dirty="0"/>
+              <a:t> позволяет задавать права через отношения между субъектами и объектами.</a:t>
+            </a:r>
+          </a:p>
+          <a:p>
+            <a:r>
+              <a:rPr lang="ru-RU" sz="4000" dirty="0"/>
+              <a:t>Базовая запись в такой модели имеет вид:</a:t>
+            </a:r>
+            <a:br>
+              <a:rPr lang="ru-RU" sz="4000" dirty="0"/>
+            </a:br>
+            <a:r>
+              <a:rPr lang="ru-RU" sz="4000" b="1" dirty="0" err="1"/>
+              <a:t>namespace:object#relation@namespace:subject</a:t>
+            </a:r>
+            <a:r>
+              <a:rPr lang="ru-RU" sz="4000" dirty="0"/>
+              <a:t>.</a:t>
+            </a:r>
+          </a:p>
+          <a:p>
+            <a:r>
+              <a:rPr lang="ru-RU" sz="4000" dirty="0"/>
+              <a:t>Например, это позволяет описывать такие отношения, как:</a:t>
+            </a:r>
+          </a:p>
+          <a:p>
+            <a:r>
+              <a:rPr lang="ru-RU" sz="4000" dirty="0"/>
+              <a:t>пользователь является владельцем курса, </a:t>
+            </a:r>
+          </a:p>
+          <a:p>
+            <a:r>
+              <a:rPr lang="ru-RU" sz="4000" dirty="0"/>
+              <a:t>пользователь является участником курса, </a:t>
+            </a:r>
+          </a:p>
+          <a:p>
+            <a:r>
+              <a:rPr lang="ru-RU" sz="4000" dirty="0"/>
+              <a:t>автор может редактировать урок, </a:t>
+            </a:r>
+          </a:p>
+          <a:p>
+            <a:r>
+              <a:rPr lang="ru-RU" sz="4000" dirty="0"/>
+              <a:t>ученик может просматривать только те материалы, к которым у него есть доступ. </a:t>
+            </a:r>
+          </a:p>
+          <a:p>
+            <a:r>
+              <a:rPr lang="ru-RU" sz="4000" dirty="0"/>
+              <a:t>Преимущество такого подхода состоит в том, что он лучше подходит для сложных прикладных систем, где доступ зависит не только от роли, но и от связи пользователя с конкретным объектом.</a:t>
+            </a:r>
           </a:p>
         </p:txBody>
       </p:sp>
@@ -3135,6 +2595,37 @@
           <a:bodyPr/>
           <a:lstStyle/>
           <a:p>
+            <a:r>
+              <a:rPr lang="ru-RU" dirty="0"/>
+              <a:t>На данном слайде представлена структура курса.</a:t>
+            </a:r>
+          </a:p>
+          <a:p>
+            <a:r>
+              <a:rPr lang="ru-RU" dirty="0"/>
+              <a:t>Курс является основной сущностью образовательной платформы и включает в себя иерархию учебного контента.</a:t>
+            </a:r>
+            <a:br>
+              <a:rPr lang="ru-RU" dirty="0"/>
+            </a:br>
+            <a:r>
+              <a:rPr lang="ru-RU" dirty="0"/>
+              <a:t>В его состав входят модули, уроки, видео, дополнительные материалы и связанные элементы взаимодействия.</a:t>
+            </a:r>
+          </a:p>
+          <a:p>
+            <a:r>
+              <a:rPr lang="ru-RU" dirty="0"/>
+              <a:t>Такая структура позволяет логически группировать учебный контент, управлять доступом на разных уровнях и формировать удобную навигацию для пользователя.</a:t>
+            </a:r>
+          </a:p>
+          <a:p>
+            <a:r>
+              <a:rPr lang="ru-RU" dirty="0"/>
+              <a:t>Кроме того, разделение курса на модули и уроки упрощает масштабирование платформы и расширение функциональности, например добавление тестов, домашних заданий или аналитики прохождения.</a:t>
+            </a:r>
+          </a:p>
+          <a:p>
             <a:endParaRPr lang="en-US" dirty="0"/>
           </a:p>
         </p:txBody>
@@ -3304,7 +2795,7 @@
           <a:p>
             <a:fld id="{7C31999D-E1F4-413D-B33E-2AE961C7E377}" type="datetimeFigureOut">
               <a:rPr lang="ru-RU" smtClean="0"/>
-              <a:t>02.05.2026</a:t>
+              <a:t>11.05.2026</a:t>
             </a:fld>
             <a:endParaRPr lang="ru-RU"/>
           </a:p>
@@ -3472,7 +2963,7 @@
           <a:p>
             <a:fld id="{7C31999D-E1F4-413D-B33E-2AE961C7E377}" type="datetimeFigureOut">
               <a:rPr lang="ru-RU" smtClean="0"/>
-              <a:t>02.05.2026</a:t>
+              <a:t>11.05.2026</a:t>
             </a:fld>
             <a:endParaRPr lang="ru-RU"/>
           </a:p>
@@ -3650,7 +3141,7 @@
           <a:p>
             <a:fld id="{7C31999D-E1F4-413D-B33E-2AE961C7E377}" type="datetimeFigureOut">
               <a:rPr lang="ru-RU" smtClean="0"/>
-              <a:t>02.05.2026</a:t>
+              <a:t>11.05.2026</a:t>
             </a:fld>
             <a:endParaRPr lang="ru-RU"/>
           </a:p>
@@ -3818,7 +3309,7 @@
           <a:p>
             <a:fld id="{7C31999D-E1F4-413D-B33E-2AE961C7E377}" type="datetimeFigureOut">
               <a:rPr lang="ru-RU" smtClean="0"/>
-              <a:t>02.05.2026</a:t>
+              <a:t>11.05.2026</a:t>
             </a:fld>
             <a:endParaRPr lang="ru-RU"/>
           </a:p>
@@ -4063,7 +3554,7 @@
           <a:p>
             <a:fld id="{7C31999D-E1F4-413D-B33E-2AE961C7E377}" type="datetimeFigureOut">
               <a:rPr lang="ru-RU" smtClean="0"/>
-              <a:t>02.05.2026</a:t>
+              <a:t>11.05.2026</a:t>
             </a:fld>
             <a:endParaRPr lang="ru-RU"/>
           </a:p>
@@ -4292,7 +3783,7 @@
           <a:p>
             <a:fld id="{7C31999D-E1F4-413D-B33E-2AE961C7E377}" type="datetimeFigureOut">
               <a:rPr lang="ru-RU" smtClean="0"/>
-              <a:t>02.05.2026</a:t>
+              <a:t>11.05.2026</a:t>
             </a:fld>
             <a:endParaRPr lang="ru-RU"/>
           </a:p>
@@ -4656,7 +4147,7 @@
           <a:p>
             <a:fld id="{7C31999D-E1F4-413D-B33E-2AE961C7E377}" type="datetimeFigureOut">
               <a:rPr lang="ru-RU" smtClean="0"/>
-              <a:t>02.05.2026</a:t>
+              <a:t>11.05.2026</a:t>
             </a:fld>
             <a:endParaRPr lang="ru-RU"/>
           </a:p>
@@ -4773,7 +4264,7 @@
           <a:p>
             <a:fld id="{7C31999D-E1F4-413D-B33E-2AE961C7E377}" type="datetimeFigureOut">
               <a:rPr lang="ru-RU" smtClean="0"/>
-              <a:t>02.05.2026</a:t>
+              <a:t>11.05.2026</a:t>
             </a:fld>
             <a:endParaRPr lang="ru-RU"/>
           </a:p>
@@ -4868,7 +4359,7 @@
           <a:p>
             <a:fld id="{7C31999D-E1F4-413D-B33E-2AE961C7E377}" type="datetimeFigureOut">
               <a:rPr lang="ru-RU" smtClean="0"/>
-              <a:t>02.05.2026</a:t>
+              <a:t>11.05.2026</a:t>
             </a:fld>
             <a:endParaRPr lang="ru-RU"/>
           </a:p>
@@ -5143,7 +4634,7 @@
           <a:p>
             <a:fld id="{7C31999D-E1F4-413D-B33E-2AE961C7E377}" type="datetimeFigureOut">
               <a:rPr lang="ru-RU" smtClean="0"/>
-              <a:t>02.05.2026</a:t>
+              <a:t>11.05.2026</a:t>
             </a:fld>
             <a:endParaRPr lang="ru-RU"/>
           </a:p>
@@ -5395,7 +4886,7 @@
           <a:p>
             <a:fld id="{7C31999D-E1F4-413D-B33E-2AE961C7E377}" type="datetimeFigureOut">
               <a:rPr lang="ru-RU" smtClean="0"/>
-              <a:t>02.05.2026</a:t>
+              <a:t>11.05.2026</a:t>
             </a:fld>
             <a:endParaRPr lang="ru-RU"/>
           </a:p>
@@ -5606,7 +5097,7 @@
           <a:p>
             <a:fld id="{7C31999D-E1F4-413D-B33E-2AE961C7E377}" type="datetimeFigureOut">
               <a:rPr lang="ru-RU" smtClean="0"/>
-              <a:t>02.05.2026</a:t>
+              <a:t>11.05.2026</a:t>
             </a:fld>
             <a:endParaRPr lang="ru-RU"/>
           </a:p>
@@ -6477,7 +5968,7 @@
         </p:nvSpPr>
         <p:spPr bwMode="auto">
           <a:xfrm>
-            <a:off x="3200342" y="6376919"/>
+            <a:off x="3294136" y="5469864"/>
             <a:ext cx="5603728" cy="338041"/>
           </a:xfrm>
           <a:prstGeom prst="rect">
@@ -6509,39 +6000,13 @@
               </a:spcAft>
             </a:pPr>
             <a:r>
-              <a:rPr lang="en-US" sz="1600" dirty="0" err="1">
-                <a:effectLst/>
-                <a:latin typeface="Times New Roman" panose="02020603050405020304" pitchFamily="18" charset="0"/>
-                <a:ea typeface="Calibri" panose="020F0502020204030204" pitchFamily="34" charset="0"/>
-                <a:cs typeface="Times New Roman" panose="02020603050405020304" pitchFamily="18" charset="0"/>
-              </a:rPr>
-              <a:t>Рис</a:t>
-            </a:r>
-            <a:r>
               <a:rPr lang="en-US" sz="1600" dirty="0">
                 <a:effectLst/>
                 <a:latin typeface="Times New Roman" panose="02020603050405020304" pitchFamily="18" charset="0"/>
                 <a:ea typeface="Calibri" panose="020F0502020204030204" pitchFamily="34" charset="0"/>
                 <a:cs typeface="Times New Roman" panose="02020603050405020304" pitchFamily="18" charset="0"/>
               </a:rPr>
-              <a:t>.</a:t>
-            </a:r>
-            <a:r>
-              <a:rPr lang="ru-RU" sz="1600" dirty="0">
-                <a:latin typeface="Times New Roman" panose="02020603050405020304" pitchFamily="18" charset="0"/>
-                <a:ea typeface="Calibri" panose="020F0502020204030204" pitchFamily="34" charset="0"/>
-                <a:cs typeface="Times New Roman" panose="02020603050405020304" pitchFamily="18" charset="0"/>
-              </a:rPr>
-              <a:t>5</a:t>
-            </a:r>
-            <a:r>
-              <a:rPr lang="en-US" sz="1600" dirty="0">
-                <a:effectLst/>
-                <a:latin typeface="Times New Roman" panose="02020603050405020304" pitchFamily="18" charset="0"/>
-                <a:ea typeface="Calibri" panose="020F0502020204030204" pitchFamily="34" charset="0"/>
-                <a:cs typeface="Times New Roman" panose="02020603050405020304" pitchFamily="18" charset="0"/>
-              </a:rPr>
-              <a:t> – </a:t>
+              <a:t>Рис.6 – </a:t>
             </a:r>
             <a:r>
               <a:rPr lang="ru-RU" sz="1600" dirty="0">
@@ -7096,36 +6561,6 @@
           <a:chExt cx="0" cy="0"/>
         </a:xfrm>
       </p:grpSpPr>
-      <p:pic>
-        <p:nvPicPr>
-          <p:cNvPr id="2" name="Рисунок 1">
-            <a:extLst>
-              <a:ext uri="{FF2B5EF4-FFF2-40B4-BE49-F238E27FC236}">
-                <a16:creationId xmlns:a16="http://schemas.microsoft.com/office/drawing/2014/main" id="{249CB7FE-F042-AAED-38FA-E4C8866F595C}"/>
-              </a:ext>
-            </a:extLst>
-          </p:cNvPr>
-          <p:cNvPicPr>
-            <a:picLocks noChangeAspect="1"/>
-          </p:cNvPicPr>
-          <p:nvPr/>
-        </p:nvPicPr>
-        <p:blipFill>
-          <a:blip r:embed="rId3"/>
-          <a:stretch>
-            <a:fillRect/>
-          </a:stretch>
-        </p:blipFill>
-        <p:spPr>
-          <a:xfrm>
-            <a:off x="1752094" y="1140001"/>
-            <a:ext cx="8687811" cy="4873832"/>
-          </a:xfrm>
-          <a:prstGeom prst="rect">
-            <a:avLst/>
-          </a:prstGeom>
-        </p:spPr>
-      </p:pic>
       <p:sp>
         <p:nvSpPr>
           <p:cNvPr id="6" name="Подзаголовок 2">
@@ -7142,7 +6577,7 @@
         </p:nvSpPr>
         <p:spPr>
           <a:xfrm>
-            <a:off x="-118334" y="301214"/>
+            <a:off x="-107449" y="0"/>
             <a:ext cx="2001563" cy="688489"/>
           </a:xfrm>
           <a:prstGeom prst="rect">
@@ -7610,7 +7045,7 @@
         </p:nvSpPr>
         <p:spPr bwMode="auto">
           <a:xfrm>
-            <a:off x="2345915" y="5995111"/>
+            <a:off x="3580044" y="3476216"/>
             <a:ext cx="7050910" cy="338041"/>
           </a:xfrm>
           <a:prstGeom prst="rect">
@@ -7643,20 +7078,11 @@
             </a:pPr>
             <a:r>
               <a:rPr lang="ru-RU" sz="1600" dirty="0">
-                <a:effectLst/>
                 <a:latin typeface="Times New Roman" panose="02020603050405020304" pitchFamily="18" charset="0"/>
                 <a:ea typeface="Calibri" panose="020F0502020204030204" pitchFamily="34" charset="0"/>
                 <a:cs typeface="Times New Roman" panose="02020603050405020304" pitchFamily="18" charset="0"/>
               </a:rPr>
-              <a:t>Рис.8</a:t>
-            </a:r>
-            <a:r>
-              <a:rPr lang="ru-RU" sz="1600" dirty="0">
-                <a:latin typeface="Times New Roman" panose="02020603050405020304" pitchFamily="18" charset="0"/>
-                <a:ea typeface="Calibri" panose="020F0502020204030204" pitchFamily="34" charset="0"/>
-                <a:cs typeface="Times New Roman" panose="02020603050405020304" pitchFamily="18" charset="0"/>
-              </a:rPr>
-              <a:t> </a:t>
+              <a:t>Таблица 1 </a:t>
             </a:r>
             <a:r>
               <a:rPr lang="ru-RU" sz="1600" dirty="0">
@@ -7673,8 +7099,256 @@
                 <a:ea typeface="Calibri" panose="020F0502020204030204" pitchFamily="34" charset="0"/>
                 <a:cs typeface="Times New Roman" panose="02020603050405020304" pitchFamily="18" charset="0"/>
               </a:rPr>
-              <a:t>П</a:t>
-            </a:r>
+              <a:t>Сравнение кодировок видео</a:t>
+            </a:r>
+            <a:endParaRPr lang="ru-RU" sz="1600" dirty="0">
+              <a:effectLst/>
+              <a:latin typeface="Times New Roman" panose="02020603050405020304" pitchFamily="18" charset="0"/>
+              <a:ea typeface="Calibri" panose="020F0502020204030204" pitchFamily="34" charset="0"/>
+              <a:cs typeface="Times New Roman" panose="02020603050405020304" pitchFamily="18" charset="0"/>
+            </a:endParaRPr>
+          </a:p>
+        </p:txBody>
+      </p:sp>
+      <p:graphicFrame>
+        <p:nvGraphicFramePr>
+          <p:cNvPr id="3" name="Объект 2">
+            <a:extLst>
+              <a:ext uri="{FF2B5EF4-FFF2-40B4-BE49-F238E27FC236}">
+                <a16:creationId xmlns:a16="http://schemas.microsoft.com/office/drawing/2014/main" id="{C96AE15D-8023-65BC-2F18-18A16C09C999}"/>
+              </a:ext>
+            </a:extLst>
+          </p:cNvPr>
+          <p:cNvGraphicFramePr>
+            <a:graphicFrameLocks noChangeAspect="1"/>
+          </p:cNvGraphicFramePr>
+          <p:nvPr>
+            <p:extLst>
+              <p:ext uri="{D42A27DB-BD31-4B8C-83A1-F6EECF244321}">
+                <p14:modId xmlns:p14="http://schemas.microsoft.com/office/powerpoint/2010/main" val="575964492"/>
+              </p:ext>
+            </p:extLst>
+          </p:nvPr>
+        </p:nvGraphicFramePr>
+        <p:xfrm>
+          <a:off x="2264326" y="177502"/>
+          <a:ext cx="9682347" cy="3279958"/>
+        </p:xfrm>
+        <a:graphic>
+          <a:graphicData uri="http://schemas.openxmlformats.org/presentationml/2006/ole">
+            <mc:AlternateContent xmlns:mc="http://schemas.openxmlformats.org/markup-compatibility/2006">
+              <mc:Choice xmlns:v="urn:schemas-microsoft-com:vml" Requires="v">
+                <p:oleObj name="Worksheet" r:id="rId3" imgW="10353658" imgH="3438545" progId="Excel.Sheet.12">
+                  <p:embed/>
+                </p:oleObj>
+              </mc:Choice>
+              <mc:Fallback>
+                <p:oleObj name="Worksheet" r:id="rId3" imgW="10353658" imgH="3438545" progId="Excel.Sheet.12">
+                  <p:embed/>
+                  <p:pic>
+                    <p:nvPicPr>
+                      <p:cNvPr id="0" name=""/>
+                      <p:cNvPicPr/>
+                      <p:nvPr/>
+                    </p:nvPicPr>
+                    <p:blipFill>
+                      <a:blip r:embed="rId4"/>
+                      <a:stretch>
+                        <a:fillRect/>
+                      </a:stretch>
+                    </p:blipFill>
+                    <p:spPr>
+                      <a:xfrm>
+                        <a:off x="2264326" y="177502"/>
+                        <a:ext cx="9682347" cy="3279958"/>
+                      </a:xfrm>
+                      <a:prstGeom prst="rect">
+                        <a:avLst/>
+                      </a:prstGeom>
+                    </p:spPr>
+                  </p:pic>
+                </p:oleObj>
+              </mc:Fallback>
+            </mc:AlternateContent>
+          </a:graphicData>
+        </a:graphic>
+      </p:graphicFrame>
+      <p:grpSp>
+        <p:nvGrpSpPr>
+          <p:cNvPr id="17" name="Группа 16">
+            <a:extLst>
+              <a:ext uri="{FF2B5EF4-FFF2-40B4-BE49-F238E27FC236}">
+                <a16:creationId xmlns:a16="http://schemas.microsoft.com/office/drawing/2014/main" id="{8591550E-240A-9814-5DFF-4093B3FD626D}"/>
+              </a:ext>
+            </a:extLst>
+          </p:cNvPr>
+          <p:cNvGrpSpPr/>
+          <p:nvPr/>
+        </p:nvGrpSpPr>
+        <p:grpSpPr>
+          <a:xfrm>
+            <a:off x="290256" y="3833013"/>
+            <a:ext cx="11611488" cy="2270601"/>
+            <a:chOff x="199512" y="3940628"/>
+            <a:chExt cx="10821342" cy="2144230"/>
+          </a:xfrm>
+        </p:grpSpPr>
+        <p:pic>
+          <p:nvPicPr>
+            <p:cNvPr id="10" name="Рисунок 9">
+              <a:extLst>
+                <a:ext uri="{FF2B5EF4-FFF2-40B4-BE49-F238E27FC236}">
+                  <a16:creationId xmlns:a16="http://schemas.microsoft.com/office/drawing/2014/main" id="{AA7A79B5-7755-660B-1AC4-78A576D60B66}"/>
+                </a:ext>
+              </a:extLst>
+            </p:cNvPr>
+            <p:cNvPicPr>
+              <a:picLocks noChangeAspect="1"/>
+            </p:cNvPicPr>
+            <p:nvPr/>
+          </p:nvPicPr>
+          <p:blipFill>
+            <a:blip r:embed="rId5" cstate="print">
+              <a:extLst>
+                <a:ext uri="{28A0092B-C50C-407E-A947-70E740481C1C}">
+                  <a14:useLocalDpi xmlns:a14="http://schemas.microsoft.com/office/drawing/2010/main" val="0"/>
+                </a:ext>
+              </a:extLst>
+            </a:blip>
+            <a:stretch>
+              <a:fillRect/>
+            </a:stretch>
+          </p:blipFill>
+          <p:spPr>
+            <a:xfrm>
+              <a:off x="199512" y="3940629"/>
+              <a:ext cx="3607114" cy="2144229"/>
+            </a:xfrm>
+            <a:prstGeom prst="rect">
+              <a:avLst/>
+            </a:prstGeom>
+          </p:spPr>
+        </p:pic>
+        <p:pic>
+          <p:nvPicPr>
+            <p:cNvPr id="12" name="Рисунок 11">
+              <a:extLst>
+                <a:ext uri="{FF2B5EF4-FFF2-40B4-BE49-F238E27FC236}">
+                  <a16:creationId xmlns:a16="http://schemas.microsoft.com/office/drawing/2014/main" id="{CAC22E25-944E-295A-EACE-257A02D78C4D}"/>
+                </a:ext>
+              </a:extLst>
+            </p:cNvPr>
+            <p:cNvPicPr>
+              <a:picLocks noChangeAspect="1"/>
+            </p:cNvPicPr>
+            <p:nvPr/>
+          </p:nvPicPr>
+          <p:blipFill>
+            <a:blip r:embed="rId6" cstate="print">
+              <a:extLst>
+                <a:ext uri="{28A0092B-C50C-407E-A947-70E740481C1C}">
+                  <a14:useLocalDpi xmlns:a14="http://schemas.microsoft.com/office/drawing/2010/main" val="0"/>
+                </a:ext>
+              </a:extLst>
+            </a:blip>
+            <a:stretch>
+              <a:fillRect/>
+            </a:stretch>
+          </p:blipFill>
+          <p:spPr>
+            <a:xfrm>
+              <a:off x="3806626" y="3940629"/>
+              <a:ext cx="3607114" cy="2144229"/>
+            </a:xfrm>
+            <a:prstGeom prst="rect">
+              <a:avLst/>
+            </a:prstGeom>
+          </p:spPr>
+        </p:pic>
+        <p:pic>
+          <p:nvPicPr>
+            <p:cNvPr id="16" name="Рисунок 15">
+              <a:extLst>
+                <a:ext uri="{FF2B5EF4-FFF2-40B4-BE49-F238E27FC236}">
+                  <a16:creationId xmlns:a16="http://schemas.microsoft.com/office/drawing/2014/main" id="{C4857D82-3D40-32CA-55F8-8DEAA32D9D8E}"/>
+                </a:ext>
+              </a:extLst>
+            </p:cNvPr>
+            <p:cNvPicPr>
+              <a:picLocks noChangeAspect="1"/>
+            </p:cNvPicPr>
+            <p:nvPr/>
+          </p:nvPicPr>
+          <p:blipFill>
+            <a:blip r:embed="rId7" cstate="print">
+              <a:extLst>
+                <a:ext uri="{28A0092B-C50C-407E-A947-70E740481C1C}">
+                  <a14:useLocalDpi xmlns:a14="http://schemas.microsoft.com/office/drawing/2010/main" val="0"/>
+                </a:ext>
+              </a:extLst>
+            </a:blip>
+            <a:stretch>
+              <a:fillRect/>
+            </a:stretch>
+          </p:blipFill>
+          <p:spPr>
+            <a:xfrm>
+              <a:off x="7413740" y="3940628"/>
+              <a:ext cx="3607114" cy="2144229"/>
+            </a:xfrm>
+            <a:prstGeom prst="rect">
+              <a:avLst/>
+            </a:prstGeom>
+          </p:spPr>
+        </p:pic>
+      </p:grpSp>
+      <p:sp>
+        <p:nvSpPr>
+          <p:cNvPr id="18" name="Надпись 2">
+            <a:extLst>
+              <a:ext uri="{FF2B5EF4-FFF2-40B4-BE49-F238E27FC236}">
+                <a16:creationId xmlns:a16="http://schemas.microsoft.com/office/drawing/2014/main" id="{14579284-C54C-C876-733D-B4D66659FEBC}"/>
+              </a:ext>
+            </a:extLst>
+          </p:cNvPr>
+          <p:cNvSpPr txBox="1">
+            <a:spLocks noChangeArrowheads="1"/>
+          </p:cNvSpPr>
+          <p:nvPr/>
+        </p:nvSpPr>
+        <p:spPr bwMode="auto">
+          <a:xfrm>
+            <a:off x="2570545" y="6141125"/>
+            <a:ext cx="7050910" cy="338041"/>
+          </a:xfrm>
+          <a:prstGeom prst="rect">
+            <a:avLst/>
+          </a:prstGeom>
+          <a:noFill/>
+          <a:ln w="9525">
+            <a:noFill/>
+            <a:miter lim="800000"/>
+            <a:headEnd/>
+            <a:tailEnd/>
+          </a:ln>
+        </p:spPr>
+        <p:txBody>
+          <a:bodyPr rot="0" vert="horz" wrap="square" lIns="91440" tIns="45720" rIns="91440" bIns="45720" anchor="t" anchorCtr="0">
+            <a:spAutoFit/>
+          </a:bodyPr>
+          <a:lstStyle/>
+          <a:p>
+            <a:pPr marL="0" marR="0" indent="0" algn="ctr">
+              <a:lnSpc>
+                <a:spcPct val="107000"/>
+              </a:lnSpc>
+              <a:spcBef>
+                <a:spcPts val="0"/>
+              </a:spcBef>
+              <a:spcAft>
+                <a:spcPts val="800"/>
+              </a:spcAft>
+            </a:pPr>
             <a:r>
               <a:rPr lang="ru-RU" sz="1600" dirty="0">
                 <a:effectLst/>
@@ -7682,7 +7356,33 @@
                 <a:ea typeface="Calibri" panose="020F0502020204030204" pitchFamily="34" charset="0"/>
                 <a:cs typeface="Times New Roman" panose="02020603050405020304" pitchFamily="18" charset="0"/>
               </a:rPr>
-              <a:t>ерекодирование видео</a:t>
+              <a:t>Рис.</a:t>
+            </a:r>
+            <a:r>
+              <a:rPr lang="en-US" sz="1600" dirty="0">
+                <a:effectLst/>
+                <a:latin typeface="Times New Roman" panose="02020603050405020304" pitchFamily="18" charset="0"/>
+                <a:ea typeface="Calibri" panose="020F0502020204030204" pitchFamily="34" charset="0"/>
+                <a:cs typeface="Times New Roman" panose="02020603050405020304" pitchFamily="18" charset="0"/>
+              </a:rPr>
+              <a:t>8</a:t>
+            </a:r>
+            <a:r>
+              <a:rPr lang="ru-RU" sz="1600" dirty="0">
+                <a:latin typeface="Times New Roman" panose="02020603050405020304" pitchFamily="18" charset="0"/>
+                <a:ea typeface="Calibri" panose="020F0502020204030204" pitchFamily="34" charset="0"/>
+                <a:cs typeface="Times New Roman" panose="02020603050405020304" pitchFamily="18" charset="0"/>
+              </a:rPr>
+              <a:t> </a:t>
+            </a:r>
+            <a:r>
+              <a:rPr lang="ru-RU" sz="1600" dirty="0">
+                <a:effectLst/>
+                <a:latin typeface="Times New Roman" panose="02020603050405020304" pitchFamily="18" charset="0"/>
+                <a:ea typeface="Calibri" panose="020F0502020204030204" pitchFamily="34" charset="0"/>
+                <a:cs typeface="Times New Roman" panose="02020603050405020304" pitchFamily="18" charset="0"/>
+              </a:rPr>
+              <a:t>– Графики сравнения кодировок</a:t>
             </a:r>
           </a:p>
         </p:txBody>
@@ -8279,8 +7979,8 @@
         </p:nvSpPr>
         <p:spPr>
           <a:xfrm>
-            <a:off x="762196" y="2678592"/>
-            <a:ext cx="10615953" cy="3416320"/>
+            <a:off x="762195" y="2401802"/>
+            <a:ext cx="10615953" cy="4154984"/>
           </a:xfrm>
           <a:prstGeom prst="rect">
             <a:avLst/>
@@ -8325,11 +8025,13 @@
                   </a:schemeClr>
                 </a:solidFill>
               </a:rPr>
-              <a:t>1.	Проведён обзор и анализ современных технологий в областях AR и AI;</a:t>
-            </a:r>
-          </a:p>
-          <a:p>
-            <a:pPr algn="just"/>
+              <a:t>1.   Проведён анализ современных образовательных платформ и их требований;</a:t>
+            </a:r>
+          </a:p>
+          <a:p>
+            <a:pPr marL="457200" indent="-457200" algn="just">
+              <a:buAutoNum type="arabicPeriod" startAt="2"/>
+            </a:pPr>
             <a:r>
               <a:rPr lang="ru-RU" sz="2400" dirty="0">
                 <a:solidFill>
@@ -8338,11 +8040,14 @@
                   </a:schemeClr>
                 </a:solidFill>
               </a:rPr>
-              <a:t>2.	Спроектирован пользовательский интерфейс;</a:t>
-            </a:r>
-          </a:p>
-          <a:p>
-            <a:pPr algn="just"/>
+              <a:t>Исследованы подходы к аутентификации, авторизации и управлению доступом;</a:t>
+            </a:r>
+          </a:p>
+          <a:p>
+            <a:pPr marL="457200" indent="-457200" algn="just">
+              <a:buFontTx/>
+              <a:buAutoNum type="arabicPeriod" startAt="2"/>
+            </a:pPr>
             <a:r>
               <a:rPr lang="ru-RU" sz="2400" dirty="0">
                 <a:solidFill>
@@ -8351,24 +8056,30 @@
                   </a:schemeClr>
                 </a:solidFill>
               </a:rPr>
-              <a:t>3.	Реализована интеграция библиотек и модулей для реализации картографического модуля и дополненной реальности;</a:t>
-            </a:r>
-          </a:p>
-          <a:p>
-            <a:pPr algn="just"/>
-            <a:r>
-              <a:rPr lang="ru-RU" sz="2400" dirty="0">
+              <a:t>Реализована собственная система авторизации и разграничения прав       доступа</a:t>
+            </a:r>
+            <a:r>
+              <a:rPr lang="en-US" sz="2400" dirty="0">
                 <a:solidFill>
                   <a:schemeClr val="tx1">
                     <a:alpha val="70000"/>
                   </a:schemeClr>
                 </a:solidFill>
               </a:rPr>
-              <a:t>4.	Разработан и настроен GPT-ассистент;</a:t>
-            </a:r>
-          </a:p>
-          <a:p>
-            <a:pPr algn="just"/>
+              <a:t>;</a:t>
+            </a:r>
+            <a:endParaRPr lang="ru-RU" sz="2400" dirty="0">
+              <a:solidFill>
+                <a:schemeClr val="tx1">
+                  <a:alpha val="70000"/>
+                </a:schemeClr>
+              </a:solidFill>
+            </a:endParaRPr>
+          </a:p>
+          <a:p>
+            <a:pPr marL="457200" indent="-457200" algn="just">
+              <a:buAutoNum type="arabicPeriod" startAt="4"/>
+            </a:pPr>
             <a:r>
               <a:rPr lang="ru-RU" sz="2400" dirty="0">
                 <a:solidFill>
@@ -8377,11 +8088,14 @@
                   </a:schemeClr>
                 </a:solidFill>
               </a:rPr>
-              <a:t>5.	Созданы методы взаимодействия пользователей с цифровым контентом в AR и AI-режиме;</a:t>
-            </a:r>
-          </a:p>
-          <a:p>
-            <a:pPr algn="just"/>
+              <a:t>Спроектирован и разработан основной функционал цифровой платформы;</a:t>
+            </a:r>
+          </a:p>
+          <a:p>
+            <a:pPr marL="457200" indent="-457200" algn="just">
+              <a:buFontTx/>
+              <a:buAutoNum type="arabicPeriod" startAt="4"/>
+            </a:pPr>
             <a:r>
               <a:rPr lang="ru-RU" sz="2400" dirty="0">
                 <a:solidFill>
@@ -8390,7 +8104,23 @@
                   </a:schemeClr>
                 </a:solidFill>
               </a:rPr>
-              <a:t>6.	Реализована система управления подписками.</a:t>
+              <a:t>Реализована интеграция библиотек и модулей для реализации обработки видео;</a:t>
+            </a:r>
+          </a:p>
+          <a:p>
+            <a:pPr marL="457200" indent="-457200" algn="just">
+              <a:buFontTx/>
+              <a:buAutoNum type="arabicPeriod" startAt="4"/>
+            </a:pPr>
+            <a:r>
+              <a:rPr lang="ru-RU" sz="2400" dirty="0">
+                <a:solidFill>
+                  <a:schemeClr val="tx1">
+                    <a:alpha val="70000"/>
+                  </a:schemeClr>
+                </a:solidFill>
+              </a:rPr>
+              <a:t>Спроектирован и реализован пользовательский интерфейс.</a:t>
             </a:r>
           </a:p>
         </p:txBody>
@@ -8641,7 +8371,7 @@
         </p:nvSpPr>
         <p:spPr>
           <a:xfrm>
-            <a:off x="728133" y="1233983"/>
+            <a:off x="762195" y="1044207"/>
             <a:ext cx="10615953" cy="1200329"/>
           </a:xfrm>
           <a:prstGeom prst="rect">
@@ -8674,27 +8404,7 @@
                   </a:schemeClr>
                 </a:solidFill>
               </a:rPr>
-              <a:t>В ходе выполнения работы было разработано веб-приложение, объединяющее функции дополненной реальности и искусственного интеллекта</a:t>
-            </a:r>
-            <a:r>
-              <a:rPr lang="ru-RU" sz="2400" dirty="0">
-                <a:solidFill>
-                  <a:srgbClr val="FF0000">
-                    <a:alpha val="70000"/>
-                  </a:srgbClr>
-                </a:solidFill>
-              </a:rPr>
-              <a:t> </a:t>
-            </a:r>
-            <a:r>
-              <a:rPr lang="ru-RU" sz="2400" dirty="0">
-                <a:solidFill>
-                  <a:schemeClr val="tx1">
-                    <a:alpha val="70000"/>
-                  </a:schemeClr>
-                </a:solidFill>
-              </a:rPr>
-              <a:t>для художников, работающих в направлении современного искусства.</a:t>
+              <a:t>В ходе выполнения работы было разработано веб-приложение, реализующее безопасную цифровую образовательную платформу для онлайн-курсов с гибким функционалом.</a:t>
             </a:r>
             <a:endParaRPr lang="ru-RU" sz="500" dirty="0">
               <a:solidFill>
@@ -8756,7 +8466,7 @@
         </p:nvSpPr>
         <p:spPr>
           <a:xfrm>
-            <a:off x="-118333" y="301214"/>
+            <a:off x="-140105" y="83500"/>
             <a:ext cx="3394934" cy="688489"/>
           </a:xfrm>
           <a:solidFill>
@@ -8799,8 +8509,8 @@
         </p:nvSpPr>
         <p:spPr>
           <a:xfrm>
-            <a:off x="615762" y="1048187"/>
-            <a:ext cx="11321922" cy="4524315"/>
+            <a:off x="435039" y="771989"/>
+            <a:ext cx="11321922" cy="5909310"/>
           </a:xfrm>
           <a:prstGeom prst="rect">
             <a:avLst/>
@@ -8815,7 +8525,124 @@
           <a:p>
             <a:r>
               <a:rPr lang="en-US" b="1" dirty="0"/>
-              <a:t>SSO</a:t>
+              <a:t>ReBAC (Relationship‑Based Access Control) </a:t>
+            </a:r>
+            <a:r>
+              <a:rPr lang="ru-RU" dirty="0"/>
+              <a:t>–</a:t>
+            </a:r>
+            <a:r>
+              <a:rPr lang="en-US" dirty="0"/>
+              <a:t> </a:t>
+            </a:r>
+            <a:r>
+              <a:rPr lang="ru-RU" dirty="0"/>
+              <a:t>способ для гибкого управления правами доступа.</a:t>
+            </a:r>
+          </a:p>
+          <a:p>
+            <a:r>
+              <a:rPr lang="en-US" b="1" dirty="0"/>
+              <a:t>JWT (JSON Web Token)</a:t>
+            </a:r>
+            <a:r>
+              <a:rPr lang="en-US" dirty="0"/>
+              <a:t> — </a:t>
+            </a:r>
+            <a:r>
+              <a:rPr lang="en-US" dirty="0" err="1"/>
+              <a:t>компактный</a:t>
+            </a:r>
+            <a:r>
+              <a:rPr lang="en-US" dirty="0"/>
+              <a:t> </a:t>
+            </a:r>
+            <a:r>
+              <a:rPr lang="en-US" dirty="0" err="1"/>
+              <a:t>формат</a:t>
+            </a:r>
+            <a:r>
+              <a:rPr lang="en-US" dirty="0"/>
+              <a:t> </a:t>
+            </a:r>
+            <a:r>
+              <a:rPr lang="en-US" dirty="0" err="1"/>
+              <a:t>токена</a:t>
+            </a:r>
+            <a:r>
+              <a:rPr lang="en-US" dirty="0"/>
+              <a:t>, </a:t>
+            </a:r>
+            <a:r>
+              <a:rPr lang="en-US" dirty="0" err="1"/>
+              <a:t>используемый</a:t>
+            </a:r>
+            <a:r>
+              <a:rPr lang="en-US" dirty="0"/>
+              <a:t> </a:t>
+            </a:r>
+            <a:r>
+              <a:rPr lang="en-US" dirty="0" err="1"/>
+              <a:t>для</a:t>
+            </a:r>
+            <a:r>
+              <a:rPr lang="en-US" dirty="0"/>
+              <a:t> </a:t>
+            </a:r>
+            <a:r>
+              <a:rPr lang="en-US" dirty="0" err="1"/>
+              <a:t>безопасной</a:t>
+            </a:r>
+            <a:r>
+              <a:rPr lang="en-US" dirty="0"/>
+              <a:t> </a:t>
+            </a:r>
+            <a:r>
+              <a:rPr lang="en-US" dirty="0" err="1"/>
+              <a:t>передачи</a:t>
+            </a:r>
+            <a:r>
+              <a:rPr lang="en-US" dirty="0"/>
+              <a:t> </a:t>
+            </a:r>
+            <a:r>
+              <a:rPr lang="en-US" dirty="0" err="1"/>
+              <a:t>данных</a:t>
+            </a:r>
+            <a:r>
+              <a:rPr lang="en-US" dirty="0"/>
+              <a:t> о </a:t>
+            </a:r>
+            <a:r>
+              <a:rPr lang="en-US" dirty="0" err="1"/>
+              <a:t>пользователе</a:t>
+            </a:r>
+            <a:r>
+              <a:rPr lang="en-US" dirty="0"/>
+              <a:t> и </a:t>
+            </a:r>
+            <a:r>
+              <a:rPr lang="en-US" dirty="0" err="1"/>
+              <a:t>его</a:t>
+            </a:r>
+            <a:r>
+              <a:rPr lang="en-US" dirty="0"/>
+              <a:t> </a:t>
+            </a:r>
+            <a:r>
+              <a:rPr lang="en-US" dirty="0" err="1"/>
+              <a:t>правах</a:t>
+            </a:r>
+            <a:r>
+              <a:rPr lang="en-US" dirty="0"/>
+              <a:t>.</a:t>
+            </a:r>
+            <a:endParaRPr lang="ru-RU" dirty="0"/>
+          </a:p>
+          <a:p>
+            <a:r>
+              <a:rPr lang="en-US" b="1" dirty="0"/>
+              <a:t>API</a:t>
             </a:r>
             <a:r>
               <a:rPr lang="ru-RU" b="1" dirty="0"/>
@@ -8823,15 +8650,7 @@
             </a:r>
             <a:r>
               <a:rPr lang="en-US" b="1" dirty="0"/>
-              <a:t>Single Sign</a:t>
-            </a:r>
-            <a:r>
-              <a:rPr lang="ru-RU" b="1" dirty="0"/>
-              <a:t>-</a:t>
-            </a:r>
-            <a:r>
-              <a:rPr lang="en-US" b="1" dirty="0"/>
-              <a:t>On</a:t>
+              <a:t>Application Programming Interface</a:t>
             </a:r>
             <a:r>
               <a:rPr lang="ru-RU" b="1" dirty="0"/>
@@ -8839,112 +8658,133 @@
             </a:r>
             <a:r>
               <a:rPr lang="ru-RU" dirty="0"/>
-              <a:t> – механизм единого входа, позволяющий пользователю после одной процедуры аутентификации получать доступ к нескольким компонентам системы без повторного ввода учетных данных.</a:t>
+              <a:t> – программный интерфейс взаимодействия между различными компонентами системы.</a:t>
             </a:r>
           </a:p>
           <a:p>
             <a:r>
               <a:rPr lang="en-US" b="1" dirty="0"/>
-              <a:t>JWT (JSON Web Token)</a:t>
-            </a:r>
-            <a:r>
-              <a:rPr lang="en-US" dirty="0"/>
-              <a:t> — </a:t>
-            </a:r>
-            <a:r>
-              <a:rPr lang="en-US" dirty="0" err="1"/>
-              <a:t>компактный</a:t>
+              <a:t>PostgreSQL</a:t>
             </a:r>
             <a:r>
               <a:rPr lang="en-US" dirty="0"/>
               <a:t> </a:t>
             </a:r>
             <a:r>
-              <a:rPr lang="en-US" dirty="0" err="1"/>
-              <a:t>формат</a:t>
+              <a:rPr lang="ru-RU" dirty="0"/>
+              <a:t>– реляционная система управления базами данных, используемая для хранения структурированной информации платформы.</a:t>
+            </a:r>
+          </a:p>
+          <a:p>
+            <a:r>
+              <a:rPr lang="en-US" b="1" dirty="0"/>
+              <a:t>Redis</a:t>
             </a:r>
             <a:r>
               <a:rPr lang="en-US" dirty="0"/>
               <a:t> </a:t>
             </a:r>
             <a:r>
-              <a:rPr lang="en-US" dirty="0" err="1"/>
-              <a:t>токена</a:t>
+              <a:rPr lang="ru-RU" dirty="0"/>
+              <a:t>– </a:t>
             </a:r>
             <a:r>
               <a:rPr lang="en-US" dirty="0"/>
-              <a:t>, </a:t>
-            </a:r>
-            <a:r>
-              <a:rPr lang="en-US" dirty="0" err="1"/>
-              <a:t>используемый</a:t>
+              <a:t>in</a:t>
+            </a:r>
+            <a:r>
+              <a:rPr lang="ru-RU" dirty="0"/>
+              <a:t>-</a:t>
+            </a:r>
+            <a:r>
+              <a:rPr lang="en-US" dirty="0"/>
+              <a:t>memory</a:t>
+            </a:r>
+            <a:r>
+              <a:rPr lang="ru-RU" dirty="0"/>
+              <a:t> хранилище данных, применяемое для кэширования, временного хранения информации и ускорения работы системы.</a:t>
+            </a:r>
+          </a:p>
+          <a:p>
+            <a:r>
+              <a:rPr lang="en-US" b="1" dirty="0"/>
+              <a:t>Kafka</a:t>
             </a:r>
             <a:r>
               <a:rPr lang="en-US" dirty="0"/>
               <a:t> </a:t>
             </a:r>
             <a:r>
-              <a:rPr lang="en-US" dirty="0" err="1"/>
-              <a:t>для</a:t>
+              <a:rPr lang="ru-RU" dirty="0"/>
+              <a:t>– распределенный брокер сообщений, используемый для организации событийного взаимодействия между компонентами системы.</a:t>
+            </a:r>
+          </a:p>
+          <a:p>
+            <a:r>
+              <a:rPr lang="en-US" b="1" dirty="0" err="1"/>
+              <a:t>Centrifugo</a:t>
             </a:r>
             <a:r>
               <a:rPr lang="en-US" dirty="0"/>
               <a:t> </a:t>
             </a:r>
             <a:r>
-              <a:rPr lang="en-US" dirty="0" err="1"/>
-              <a:t>безопасной</a:t>
+              <a:rPr lang="ru-RU" dirty="0"/>
+              <a:t>– платформа для обмена сообщениями и доставки событий в режиме реального времени.</a:t>
+            </a:r>
+          </a:p>
+          <a:p>
+            <a:r>
+              <a:rPr lang="ru-RU" b="1" dirty="0"/>
+              <a:t>Объектное хранилище</a:t>
+            </a:r>
+            <a:r>
+              <a:rPr lang="ru-RU" dirty="0"/>
+              <a:t> – способ хранения файлов и связанных с ними метаданных в виде объектов.</a:t>
+            </a:r>
+          </a:p>
+          <a:p>
+            <a:r>
+              <a:rPr lang="en-US" b="1" dirty="0"/>
+              <a:t>S</a:t>
+            </a:r>
+            <a:r>
+              <a:rPr lang="ru-RU" b="1" dirty="0"/>
+              <a:t>3-совместимое хранилище</a:t>
+            </a:r>
+            <a:r>
+              <a:rPr lang="ru-RU" dirty="0"/>
+              <a:t> – объектное хранилище, поддерживающее интерфейсы взаимодействия, совместимые с </a:t>
             </a:r>
             <a:r>
               <a:rPr lang="en-US" dirty="0"/>
-              <a:t> </a:t>
-            </a:r>
-            <a:r>
-              <a:rPr lang="en-US" dirty="0" err="1"/>
-              <a:t>передачи</a:t>
-            </a:r>
-            <a:r>
-              <a:rPr lang="en-US" dirty="0"/>
-              <a:t> </a:t>
-            </a:r>
-            <a:r>
-              <a:rPr lang="en-US" dirty="0" err="1"/>
-              <a:t>данных</a:t>
-            </a:r>
-            <a:r>
-              <a:rPr lang="en-US" dirty="0"/>
-              <a:t> о </a:t>
-            </a:r>
-            <a:r>
-              <a:rPr lang="en-US" dirty="0" err="1"/>
-              <a:t>пользователе</a:t>
-            </a:r>
-            <a:r>
-              <a:rPr lang="en-US" dirty="0"/>
-              <a:t> и </a:t>
-            </a:r>
-            <a:r>
-              <a:rPr lang="en-US" dirty="0" err="1"/>
-              <a:t>его</a:t>
-            </a:r>
-            <a:r>
-              <a:rPr lang="en-US" dirty="0"/>
-              <a:t> </a:t>
-            </a:r>
-            <a:r>
-              <a:rPr lang="en-US" dirty="0" err="1"/>
-              <a:t>правах</a:t>
-            </a:r>
-            <a:r>
-              <a:rPr lang="en-US" dirty="0"/>
-              <a:t>.</a:t>
-            </a:r>
-            <a:endParaRPr lang="ru-RU" dirty="0"/>
+              <a:t>Amazon S</a:t>
+            </a:r>
+            <a:r>
+              <a:rPr lang="ru-RU" dirty="0"/>
+              <a:t>3.</a:t>
+            </a:r>
+            <a:endParaRPr lang="en-US" dirty="0"/>
           </a:p>
           <a:p>
             <a:r>
               <a:rPr lang="en-US" b="1" dirty="0"/>
-              <a:t>API</a:t>
+              <a:t>OAuth</a:t>
+            </a:r>
+            <a:r>
+              <a:rPr lang="ru-RU" b="1" dirty="0"/>
+              <a:t> 2.0</a:t>
+            </a:r>
+            <a:r>
+              <a:rPr lang="ru-RU" dirty="0"/>
+              <a:t> – протокол авторизации, обеспечивающий делегированный доступ к защищенным ресурсам.</a:t>
+            </a:r>
+            <a:endParaRPr lang="en-US" dirty="0"/>
+          </a:p>
+          <a:p>
+            <a:r>
+              <a:rPr lang="en-US" b="1" dirty="0"/>
+              <a:t>PKCE</a:t>
             </a:r>
             <a:r>
               <a:rPr lang="ru-RU" b="1" dirty="0"/>
@@ -8952,120 +8792,54 @@
             </a:r>
             <a:r>
               <a:rPr lang="en-US" b="1" dirty="0"/>
-              <a:t>Application Programming Interface</a:t>
+              <a:t>Proof Key for Code Exchange</a:t>
             </a:r>
             <a:r>
               <a:rPr lang="ru-RU" b="1" dirty="0"/>
-              <a:t>)</a:t>
+              <a:t>) - </a:t>
             </a:r>
             <a:r>
               <a:rPr lang="ru-RU" dirty="0"/>
-              <a:t> – программный интерфейс взаимодействия между различными компонентами системы.</a:t>
+              <a:t>расширение протокола </a:t>
+            </a:r>
+            <a:r>
+              <a:rPr lang="en-US" dirty="0"/>
+              <a:t>OAuth </a:t>
+            </a:r>
+            <a:r>
+              <a:rPr lang="ru-RU" dirty="0"/>
+              <a:t>2.0, которое повышает безопасность процесса авторизации и защищает от утечки </a:t>
+            </a:r>
+            <a:r>
+              <a:rPr lang="en-US" dirty="0"/>
+              <a:t>authorization code</a:t>
+            </a:r>
+            <a:r>
+              <a:rPr lang="ru-RU" dirty="0"/>
+              <a:t>. </a:t>
             </a:r>
           </a:p>
           <a:p>
             <a:r>
               <a:rPr lang="en-US" b="1" dirty="0"/>
-              <a:t>PostgreSQL</a:t>
+              <a:t>OIDC (OpenID Connect)</a:t>
+            </a:r>
+            <a:r>
+              <a:rPr lang="ru-RU" dirty="0"/>
+              <a:t> – протокол аутентификации, построенный поверх </a:t>
             </a:r>
             <a:r>
               <a:rPr lang="en-US" dirty="0"/>
-              <a:t> </a:t>
+              <a:t>OAuth</a:t>
             </a:r>
             <a:r>
               <a:rPr lang="ru-RU" dirty="0"/>
-              <a:t>– реляционная система управления базами данных, используемая для хранения структурированной информации платформы.</a:t>
-            </a:r>
-          </a:p>
-          <a:p>
-            <a:r>
-              <a:rPr lang="en-US" b="1" dirty="0"/>
-              <a:t>Redis</a:t>
-            </a:r>
-            <a:r>
-              <a:rPr lang="en-US" dirty="0"/>
-              <a:t> </a:t>
-            </a:r>
-            <a:r>
-              <a:rPr lang="ru-RU" dirty="0"/>
-              <a:t>– </a:t>
-            </a:r>
-            <a:r>
-              <a:rPr lang="en-US" dirty="0"/>
-              <a:t>in</a:t>
-            </a:r>
-            <a:r>
-              <a:rPr lang="ru-RU" dirty="0"/>
-              <a:t>-</a:t>
-            </a:r>
-            <a:r>
-              <a:rPr lang="en-US" dirty="0"/>
-              <a:t>memory</a:t>
-            </a:r>
-            <a:r>
-              <a:rPr lang="ru-RU" dirty="0"/>
-              <a:t> хранилище данных, применяемое для кэширования, временного хранения информации и ускорения работы системы.</a:t>
-            </a:r>
-          </a:p>
-          <a:p>
-            <a:r>
-              <a:rPr lang="en-US" b="1" dirty="0"/>
-              <a:t>Kafka</a:t>
-            </a:r>
-            <a:r>
-              <a:rPr lang="en-US" dirty="0"/>
-              <a:t> </a:t>
-            </a:r>
-            <a:r>
-              <a:rPr lang="ru-RU" dirty="0"/>
-              <a:t>– распределенный брокер сообщений, используемый для организации событийного взаимодействия между компонентами системы.</a:t>
-            </a:r>
-          </a:p>
-          <a:p>
-            <a:r>
-              <a:rPr lang="en-US" b="1" dirty="0" err="1"/>
-              <a:t>Centrifugo</a:t>
-            </a:r>
-            <a:r>
-              <a:rPr lang="en-US" dirty="0"/>
-              <a:t> </a:t>
-            </a:r>
-            <a:r>
-              <a:rPr lang="ru-RU" dirty="0"/>
-              <a:t>– платформа для обмена сообщениями и доставки событий в режиме реального времени.</a:t>
-            </a:r>
-          </a:p>
-          <a:p>
-            <a:r>
-              <a:rPr lang="ru-RU" b="1" dirty="0"/>
-              <a:t>Объектное хранилище</a:t>
-            </a:r>
-            <a:r>
-              <a:rPr lang="ru-RU" dirty="0"/>
-              <a:t> – способ хранения файлов и связанных с ними метаданных в виде объектов.</a:t>
-            </a:r>
-          </a:p>
-          <a:p>
-            <a:r>
-              <a:rPr lang="en-US" b="1" dirty="0"/>
-              <a:t>S</a:t>
-            </a:r>
-            <a:r>
-              <a:rPr lang="ru-RU" b="1" dirty="0"/>
-              <a:t>3-совместимое хранилище</a:t>
-            </a:r>
-            <a:r>
-              <a:rPr lang="ru-RU" dirty="0"/>
-              <a:t> – объектное хранилище, поддерживающее интерфейсы взаимодействия, совместимые с </a:t>
-            </a:r>
-            <a:r>
-              <a:rPr lang="en-US" dirty="0"/>
-              <a:t>Amazon S</a:t>
-            </a:r>
-            <a:r>
-              <a:rPr lang="ru-RU" dirty="0"/>
-              <a:t>3.</a:t>
-            </a:r>
+              <a:t> 2.0 и позволяющий подтверждать личность пользователя.</a:t>
+            </a:r>
+            <a:endParaRPr lang="en-US" dirty="0"/>
+          </a:p>
+          <a:p>
+            <a:endParaRPr lang="ru-RU" dirty="0"/>
           </a:p>
         </p:txBody>
       </p:sp>
@@ -11260,7 +11034,24 @@
                 <a:ea typeface="Calibri" panose="020F0502020204030204" pitchFamily="34" charset="0"/>
                 <a:cs typeface="Times New Roman" panose="02020603050405020304" pitchFamily="18" charset="0"/>
               </a:rPr>
-              <a:t>Рис. 2 – Структура проекта</a:t>
+              <a:t>Рис. 2 – </a:t>
+            </a:r>
+            <a:r>
+              <a:rPr lang="ru-RU" sz="1600" dirty="0">
+                <a:latin typeface="Times New Roman" panose="02020603050405020304" pitchFamily="18" charset="0"/>
+                <a:ea typeface="Calibri" panose="020F0502020204030204" pitchFamily="34" charset="0"/>
+                <a:cs typeface="Times New Roman" panose="02020603050405020304" pitchFamily="18" charset="0"/>
+              </a:rPr>
+              <a:t>Архитектура</a:t>
+            </a:r>
+            <a:r>
+              <a:rPr lang="ru-RU" sz="1600" dirty="0">
+                <a:effectLst/>
+                <a:latin typeface="Times New Roman" panose="02020603050405020304" pitchFamily="18" charset="0"/>
+                <a:ea typeface="Calibri" panose="020F0502020204030204" pitchFamily="34" charset="0"/>
+                <a:cs typeface="Times New Roman" panose="02020603050405020304" pitchFamily="18" charset="0"/>
+              </a:rPr>
+              <a:t> проекта</a:t>
             </a:r>
           </a:p>
         </p:txBody>
@@ -11301,7 +11092,7 @@
         </p:spPr>
         <p:txBody>
           <a:bodyPr vert="horz" lIns="274320" tIns="45720" rIns="91440" bIns="45720" rtlCol="0">
-            <a:normAutofit/>
+            <a:normAutofit fontScale="85000" lnSpcReduction="10000"/>
           </a:bodyPr>
           <a:lstStyle>
             <a:lvl1pPr marL="0" indent="0" algn="ctr" defTabSz="914400" rtl="0" eaLnBrk="1" latinLnBrk="0" hangingPunct="1">
@@ -11477,17 +11268,17 @@
                   </a:schemeClr>
                 </a:solidFill>
               </a:rPr>
-              <a:t>Структура проекта</a:t>
+              <a:t>Архитектура проекта</a:t>
             </a:r>
           </a:p>
         </p:txBody>
       </p:sp>
       <p:pic>
         <p:nvPicPr>
-          <p:cNvPr id="3" name="Рисунок 2">
+          <p:cNvPr id="8" name="Рисунок 7">
             <a:extLst>
               <a:ext uri="{FF2B5EF4-FFF2-40B4-BE49-F238E27FC236}">
-                <a16:creationId xmlns:a16="http://schemas.microsoft.com/office/drawing/2014/main" id="{81C353F1-E55C-57CA-7C15-778EB505B472}"/>
+                <a16:creationId xmlns:a16="http://schemas.microsoft.com/office/drawing/2014/main" id="{0A3295CC-8D1F-5E1A-FC85-339E3B2BF29F}"/>
               </a:ext>
             </a:extLst>
           </p:cNvPr>
@@ -11504,14 +11295,15 @@
               </a:ext>
             </a:extLst>
           </a:blip>
+          <a:srcRect r="7529"/>
           <a:stretch>
             <a:fillRect/>
           </a:stretch>
         </p:blipFill>
         <p:spPr>
           <a:xfrm>
-            <a:off x="318883" y="941105"/>
-            <a:ext cx="12192000" cy="5312189"/>
+            <a:off x="458993" y="921970"/>
+            <a:ext cx="11385053" cy="5364510"/>
           </a:xfrm>
           <a:prstGeom prst="rect">
             <a:avLst/>
@@ -11569,7 +11361,7 @@
         <p:spPr>
           <a:xfrm>
             <a:off x="-118334" y="301214"/>
-            <a:ext cx="6007506" cy="688489"/>
+            <a:ext cx="5659163" cy="688489"/>
           </a:xfrm>
           <a:solidFill>
             <a:srgbClr val="F99F89"/>
@@ -11598,7 +11390,7 @@
                   </a:schemeClr>
                 </a:solidFill>
               </a:rPr>
-              <a:t>Механизмы авторизации</a:t>
+              <a:t>Механизм авторизации</a:t>
             </a:r>
           </a:p>
         </p:txBody>
@@ -11695,7 +11487,7 @@
         <p:spPr>
           <a:xfrm>
             <a:off x="469648" y="3818735"/>
-            <a:ext cx="5331935" cy="1938992"/>
+            <a:ext cx="5331935" cy="1569660"/>
           </a:xfrm>
           <a:prstGeom prst="rect">
             <a:avLst/>
@@ -11720,14 +11512,14 @@
           <a:p>
             <a:pPr algn="just"/>
             <a:r>
-              <a:rPr lang="ru-RU" sz="2400" b="1" dirty="0" err="1">
+              <a:rPr lang="en-US" sz="2400" b="1" dirty="0">
                 <a:solidFill>
                   <a:schemeClr val="tx1">
                     <a:alpha val="70000"/>
                   </a:schemeClr>
                 </a:solidFill>
               </a:rPr>
-              <a:t>OAuth</a:t>
+              <a:t>OIDC </a:t>
             </a:r>
             <a:r>
               <a:rPr lang="ru-RU" sz="2400" b="1" dirty="0">
@@ -11737,7 +11529,7 @@
                   </a:schemeClr>
                 </a:solidFill>
               </a:rPr>
-              <a:t> 2.0 </a:t>
+              <a:t> </a:t>
             </a:r>
             <a:r>
               <a:rPr lang="ru-RU" sz="2400" dirty="0">
@@ -11747,7 +11539,7 @@
                   </a:schemeClr>
                 </a:solidFill>
               </a:rPr>
-              <a:t>позволяет пользователям предоставлять приложению доступ к определённым данным или функциям своего аккаунта, не передавая свои учётные данные (логин и пароль</a:t>
+              <a:t>работает поверх </a:t>
             </a:r>
             <a:r>
               <a:rPr lang="en-US" sz="2400" dirty="0">
@@ -11757,7 +11549,17 @@
                   </a:schemeClr>
                 </a:solidFill>
               </a:rPr>
-              <a:t>).</a:t>
+              <a:t>OAuth 2.0 </a:t>
+            </a:r>
+            <a:r>
+              <a:rPr lang="ru-RU" sz="2400" dirty="0">
+                <a:solidFill>
+                  <a:schemeClr val="tx1">
+                    <a:alpha val="70000"/>
+                  </a:schemeClr>
+                </a:solidFill>
+              </a:rPr>
+              <a:t>и позволяет безопасно подтвердить личность пользователя через интегрированные внешние сервисы</a:t>
             </a:r>
             <a:endParaRPr lang="ru-RU" sz="500" dirty="0">
               <a:solidFill>
@@ -11997,134 +11799,112 @@
           </a:p>
         </p:txBody>
       </p:sp>
-      <p:grpSp>
-        <p:nvGrpSpPr>
-          <p:cNvPr id="7" name="Group 6">
+      <p:sp>
+        <p:nvSpPr>
+          <p:cNvPr id="12" name="Надпись 2"/>
+          <p:cNvSpPr txBox="1">
+            <a:spLocks noChangeArrowheads="1"/>
+          </p:cNvSpPr>
+          <p:nvPr/>
+        </p:nvSpPr>
+        <p:spPr bwMode="auto">
+          <a:xfrm>
+            <a:off x="6069872" y="6140001"/>
+            <a:ext cx="5538653" cy="338041"/>
+          </a:xfrm>
+          <a:prstGeom prst="rect">
+            <a:avLst/>
+          </a:prstGeom>
+          <a:noFill/>
+          <a:ln w="9525">
+            <a:noFill/>
+            <a:miter lim="800000"/>
+            <a:headEnd/>
+            <a:tailEnd/>
+          </a:ln>
+        </p:spPr>
+        <p:txBody>
+          <a:bodyPr rot="0" vert="horz" wrap="square" lIns="0" tIns="45720" rIns="91440" bIns="45720" anchor="t" anchorCtr="0">
+            <a:spAutoFit/>
+          </a:bodyPr>
+          <a:lstStyle/>
+          <a:p>
+            <a:pPr marL="0" marR="0" indent="450215" algn="ctr">
+              <a:lnSpc>
+                <a:spcPct val="107000"/>
+              </a:lnSpc>
+              <a:spcBef>
+                <a:spcPts val="0"/>
+              </a:spcBef>
+              <a:spcAft>
+                <a:spcPts val="800"/>
+              </a:spcAft>
+            </a:pPr>
+            <a:r>
+              <a:rPr lang="ru-RU" sz="1600" dirty="0">
+                <a:effectLst/>
+                <a:latin typeface="Times New Roman" panose="02020603050405020304" pitchFamily="18" charset="0"/>
+                <a:ea typeface="Calibri" panose="020F0502020204030204" pitchFamily="34" charset="0"/>
+                <a:cs typeface="Times New Roman" panose="02020603050405020304" pitchFamily="18" charset="0"/>
+              </a:rPr>
+              <a:t>Рис. </a:t>
+            </a:r>
+            <a:r>
+              <a:rPr lang="en-US" sz="1600" dirty="0">
+                <a:latin typeface="Times New Roman" panose="02020603050405020304" pitchFamily="18" charset="0"/>
+                <a:ea typeface="Calibri" panose="020F0502020204030204" pitchFamily="34" charset="0"/>
+                <a:cs typeface="Times New Roman" panose="02020603050405020304" pitchFamily="18" charset="0"/>
+              </a:rPr>
+              <a:t>3</a:t>
+            </a:r>
+            <a:r>
+              <a:rPr lang="ru-RU" sz="1600" dirty="0">
+                <a:effectLst/>
+                <a:latin typeface="Times New Roman" panose="02020603050405020304" pitchFamily="18" charset="0"/>
+                <a:ea typeface="Calibri" panose="020F0502020204030204" pitchFamily="34" charset="0"/>
+                <a:cs typeface="Times New Roman" panose="02020603050405020304" pitchFamily="18" charset="0"/>
+              </a:rPr>
+              <a:t> – Блок-схема авторизации пользователя</a:t>
+            </a:r>
+          </a:p>
+        </p:txBody>
+      </p:sp>
+      <p:pic>
+        <p:nvPicPr>
+          <p:cNvPr id="6" name="Рисунок 5">
             <a:extLst>
               <a:ext uri="{FF2B5EF4-FFF2-40B4-BE49-F238E27FC236}">
-                <a16:creationId xmlns:a16="http://schemas.microsoft.com/office/drawing/2014/main" id="{0880DA64-B719-4F2D-8374-3E36244CFDEC}"/>
+                <a16:creationId xmlns:a16="http://schemas.microsoft.com/office/drawing/2014/main" id="{EAFD2AFC-77BD-9A9A-3AF5-99147BB1F904}"/>
               </a:ext>
             </a:extLst>
           </p:cNvPr>
-          <p:cNvGrpSpPr/>
+          <p:cNvPicPr>
+            <a:picLocks noChangeAspect="1"/>
+          </p:cNvPicPr>
           <p:nvPr/>
-        </p:nvGrpSpPr>
-        <p:grpSpPr>
+        </p:nvPicPr>
+        <p:blipFill>
+          <a:blip r:embed="rId3">
+            <a:extLst>
+              <a:ext uri="{28A0092B-C50C-407E-A947-70E740481C1C}">
+                <a14:useLocalDpi xmlns:a14="http://schemas.microsoft.com/office/drawing/2010/main" val="0"/>
+              </a:ext>
+            </a:extLst>
+          </a:blip>
+          <a:stretch>
+            <a:fillRect/>
+          </a:stretch>
+        </p:blipFill>
+        <p:spPr>
           <a:xfrm>
-            <a:off x="6069872" y="338218"/>
-            <a:ext cx="5538653" cy="6139824"/>
-            <a:chOff x="6069872" y="338218"/>
-            <a:chExt cx="5538653" cy="6139824"/>
+            <a:off x="6390419" y="297272"/>
+            <a:ext cx="4883594" cy="5842729"/>
           </a:xfrm>
-        </p:grpSpPr>
-        <p:sp>
-          <p:nvSpPr>
-            <p:cNvPr id="12" name="Надпись 2"/>
-            <p:cNvSpPr txBox="1">
-              <a:spLocks noChangeArrowheads="1"/>
-            </p:cNvSpPr>
-            <p:nvPr/>
-          </p:nvSpPr>
-          <p:spPr bwMode="auto">
-            <a:xfrm>
-              <a:off x="6069872" y="6140001"/>
-              <a:ext cx="5538653" cy="338041"/>
-            </a:xfrm>
-            <a:prstGeom prst="rect">
-              <a:avLst/>
-            </a:prstGeom>
-            <a:noFill/>
-            <a:ln w="9525">
-              <a:noFill/>
-              <a:miter lim="800000"/>
-              <a:headEnd/>
-              <a:tailEnd/>
-            </a:ln>
-          </p:spPr>
-          <p:txBody>
-            <a:bodyPr rot="0" vert="horz" wrap="square" lIns="0" tIns="45720" rIns="91440" bIns="45720" anchor="t" anchorCtr="0">
-              <a:spAutoFit/>
-            </a:bodyPr>
-            <a:lstStyle/>
-            <a:p>
-              <a:pPr marL="0" marR="0" indent="450215" algn="ctr">
-                <a:lnSpc>
-                  <a:spcPct val="107000"/>
-                </a:lnSpc>
-                <a:spcBef>
-                  <a:spcPts val="0"/>
-                </a:spcBef>
-                <a:spcAft>
-                  <a:spcPts val="800"/>
-                </a:spcAft>
-              </a:pPr>
-              <a:r>
-                <a:rPr lang="ru-RU" sz="1600" dirty="0">
-                  <a:effectLst/>
-                  <a:latin typeface="Times New Roman" panose="02020603050405020304" pitchFamily="18" charset="0"/>
-                  <a:ea typeface="Calibri" panose="020F0502020204030204" pitchFamily="34" charset="0"/>
-                  <a:cs typeface="Times New Roman" panose="02020603050405020304" pitchFamily="18" charset="0"/>
-                </a:rPr>
-                <a:t>Рис. </a:t>
-              </a:r>
-              <a:r>
-                <a:rPr lang="en-US" sz="1600" dirty="0">
-                  <a:effectLst/>
-                  <a:latin typeface="Times New Roman" panose="02020603050405020304" pitchFamily="18" charset="0"/>
-                  <a:ea typeface="Calibri" panose="020F0502020204030204" pitchFamily="34" charset="0"/>
-                  <a:cs typeface="Times New Roman" panose="02020603050405020304" pitchFamily="18" charset="0"/>
-                </a:rPr>
-                <a:t>4</a:t>
-              </a:r>
-              <a:r>
-                <a:rPr lang="ru-RU" sz="1600" dirty="0">
-                  <a:effectLst/>
-                  <a:latin typeface="Times New Roman" panose="02020603050405020304" pitchFamily="18" charset="0"/>
-                  <a:ea typeface="Calibri" panose="020F0502020204030204" pitchFamily="34" charset="0"/>
-                  <a:cs typeface="Times New Roman" panose="02020603050405020304" pitchFamily="18" charset="0"/>
-                </a:rPr>
-                <a:t> – Блок-схема аутентификации пользователя</a:t>
-              </a:r>
-            </a:p>
-          </p:txBody>
-        </p:sp>
-        <p:pic>
-          <p:nvPicPr>
-            <p:cNvPr id="4" name="Picture 3">
-              <a:extLst>
-                <a:ext uri="{FF2B5EF4-FFF2-40B4-BE49-F238E27FC236}">
-                  <a16:creationId xmlns:a16="http://schemas.microsoft.com/office/drawing/2014/main" id="{EB9A5435-0B10-4089-AB11-4E401069C5C4}"/>
-                </a:ext>
-              </a:extLst>
-            </p:cNvPr>
-            <p:cNvPicPr>
-              <a:picLocks noChangeAspect="1"/>
-            </p:cNvPicPr>
-            <p:nvPr/>
-          </p:nvPicPr>
-          <p:blipFill>
-            <a:blip r:embed="rId3">
-              <a:extLst>
-                <a:ext uri="{28A0092B-C50C-407E-A947-70E740481C1C}">
-                  <a14:useLocalDpi xmlns:a14="http://schemas.microsoft.com/office/drawing/2010/main" val="0"/>
-                </a:ext>
-              </a:extLst>
-            </a:blip>
-            <a:stretch>
-              <a:fillRect/>
-            </a:stretch>
-          </p:blipFill>
-          <p:spPr>
-            <a:xfrm>
-              <a:off x="7084467" y="338218"/>
-              <a:ext cx="3865061" cy="5801783"/>
-            </a:xfrm>
-            <a:prstGeom prst="rect">
-              <a:avLst/>
-            </a:prstGeom>
-          </p:spPr>
-        </p:pic>
-      </p:grpSp>
+          <a:prstGeom prst="rect">
+            <a:avLst/>
+          </a:prstGeom>
+        </p:spPr>
+      </p:pic>
     </p:spTree>
     <p:extLst>
       <p:ext uri="{BB962C8B-B14F-4D97-AF65-F5344CB8AC3E}">
@@ -12490,12 +12270,11 @@
             </a:r>
             <a:r>
               <a:rPr lang="en-US" sz="1600" dirty="0">
-                <a:effectLst/>
                 <a:latin typeface="Times New Roman" panose="02020603050405020304" pitchFamily="18" charset="0"/>
                 <a:ea typeface="Calibri" panose="020F0502020204030204" pitchFamily="34" charset="0"/>
                 <a:cs typeface="Times New Roman" panose="02020603050405020304" pitchFamily="18" charset="0"/>
               </a:rPr>
-              <a:t>5</a:t>
+              <a:t>4</a:t>
             </a:r>
             <a:r>
               <a:rPr lang="ru-RU" sz="1600" dirty="0">
@@ -13004,12 +12783,13 @@
               <a:t>Рис.</a:t>
             </a:r>
             <a:r>
-              <a:rPr lang="ru-RU" sz="1600" dirty="0">
+              <a:rPr lang="en-US" sz="1600" dirty="0">
+                <a:effectLst/>
                 <a:latin typeface="Times New Roman" panose="02020603050405020304" pitchFamily="18" charset="0"/>
                 <a:ea typeface="Calibri" panose="020F0502020204030204" pitchFamily="34" charset="0"/>
                 <a:cs typeface="Times New Roman" panose="02020603050405020304" pitchFamily="18" charset="0"/>
               </a:rPr>
-              <a:t>6</a:t>
+              <a:t>5</a:t>
             </a:r>
             <a:r>
               <a:rPr lang="ru-RU" sz="1600" dirty="0">

</xml_diff>